<commit_message>
Revision 3: research-before-plan, cost visibility, fix /chronicle, beginner skills
- Reorder lab-03 habits: /research before /plan (with updated cost tips)
- Add a cost-analysis checkpoint using /usage, asking Copilot to summarize
  token/cost savings from /compact, /new, and /handoff
- Fix /chronicles -> real /chronicle standup and /chronicle cost-tips
  subcommands across lab-03, lab-04, templates, README, and slides
- Verify section in lab-03 now also spins up the web app to demo the fix live,
  not just npm test
- Rename sample-app skills to be beginner-friendly and git-free:
  task-id-guard -> duplicate-task-checker, release-notes-writer -> standup-recap
  (standup-recap now reads tasks.json instead of git log)
- Update lab-02, lab-03's /create-skill example, copilot-instructions.md,
  sample-app/README.md, and slides/build.js to match
- Rebuild and re-verify slide deck (11 slides, no stale references)

Co-authored-by: Copilot <223556219+Copilot@users.noreply.github.com>
</commit_message>
<xml_diff>
--- a/slides/copilot-cli-lab.pptx
+++ b/slides/copilot-cli-lab.pptx
@@ -4521,7 +4521,7 @@
                 <a:ea typeface="Calibri" pitchFamily="34" charset="-122"/>
                 <a:cs typeface="Calibri" pitchFamily="34" charset="-120"/>
               </a:rPr>
-              <a:t>Ask Copilot to review the code and watch the pre-built task-id-guard skill kick in.</a:t>
+              <a:t>Ask Copilot to review the code and watch the pre-built duplicate-task-checker skill kick in.</a:t>
             </a:r>
             <a:endParaRPr lang="en-US" sz="1400" dirty="0"/>
           </a:p>
@@ -4797,7 +4797,7 @@
                 <a:ea typeface="Calibri" pitchFamily="34" charset="-122"/>
                 <a:cs typeface="Calibri" pitchFamily="34" charset="-120"/>
               </a:rPr>
-              <a:t>Nine slash commands, one real bug, five cost-saving habits - plan, research, and parallelize before you spend a single token.</a:t>
+              <a:t>Nine slash commands, one real bug, five cost-saving habits - research, plan, and parallelize before you spend a single token.</a:t>
             </a:r>
             <a:endParaRPr lang="en-US" sz="1500" dirty="0"/>
           </a:p>
@@ -5126,7 +5126,7 @@
                 <a:ea typeface="Calibri" pitchFamily="34" charset="-122"/>
                 <a:cs typeface="Calibri" pitchFamily="34" charset="-120"/>
               </a:rPr>
-              <a:t>A /chronicles cost-tip template plus a 9am scheduled issue triage (/every) - the team's morning report writes itself.</a:t>
+              <a:t>A /chronicle cost-tip template plus a 9am scheduled issue triage (/every) - the team's morning report writes itself.</a:t>
             </a:r>
             <a:endParaRPr lang="en-US" sz="1500" dirty="0"/>
           </a:p>

</xml_diff>

<commit_message>
Revision 6: model choice, cache tokens, 3-terminal divide-and-conquer, pricing slides
- lab-00: confirm Auto model for the first lab
- lab-01: add cache-token explainer (1st/2nd loop) and switch to a fixed
  model (Sonnet 5) from here through the rest of the labs
- lab-03: /every-style three-terminal exercise for /research -> /plan ->
  /fleet, mirroring the divide-and-conquer workshop pattern
- lab-04: /every example now minute-level for live workshop demos; add
  GitHub Copilot App install + quickstart instructions
- lab-06: expand with usage-based billing, layered budgets, and pricing
  optimization levers
- slides: add 4 new concept slides (Context Window & Tokens, Two Biggest
  Levers, Divide and Conquer, Pricing & Budgeting) in the existing Coral
  Energy style, rebuilt and QA'd
- README: update lab agenda/timing table for the expanded content

Co-authored-by: Copilot <223556219+Copilot@users.noreply.github.com>
</commit_message>
<xml_diff>
--- a/slides/copilot-cli-lab.pptx
+++ b/slides/copilot-cli-lab.pptx
@@ -16,9 +16,13 @@
     <p:sldId id="264" r:id="rId10"/>
     <p:sldId id="265" r:id="rId11"/>
     <p:sldId id="266" r:id="rId12"/>
+    <p:sldId id="267" r:id="rId13"/>
+    <p:sldId id="268" r:id="rId14"/>
+    <p:sldId id="269" r:id="rId15"/>
+    <p:sldId id="270" r:id="rId16"/>
   </p:sldIdLst>
   <p:notesMasterIdLst>
-    <p:notesMasterId r:id="rId13"/>
+    <p:notesMasterId r:id="rId17"/>
   </p:notesMasterIdLst>
   <p:sldSz cx="9144000" cy="5143500"/>
   <p:notesSz cx="5143500" cy="9144000"/>
@@ -712,6 +716,358 @@
             <a:fld id="{F7021451-1387-4CA6-816F-3879F97B5CBC}" type="slidenum">
               <a:rPr lang="en-US"/>
               <a:t>11</a:t>
+            </a:fld>
+            <a:endParaRPr lang="en-US"/>
+          </a:p>
+        </p:txBody>
+      </p:sp>
+    </p:spTree>
+    <p:extLst>
+      <p:ext uri="{BB962C8B-B14F-4D97-AF65-F5344CB8AC3E}">
+        <p14:creationId xmlns:p14="http://schemas.microsoft.com/office/powerpoint/2010/main" val="1024086991"/>
+      </p:ext>
+    </p:extLst>
+  </p:cSld>
+  <p:clrMapOvr>
+    <a:masterClrMapping/>
+  </p:clrMapOvr>
+</p:notes>
+</file>
+
+<file path=ppt/notesSlides/notesSlide12.xml><?xml version="1.0" encoding="utf-8"?>
+<p:notes xmlns:a="http://schemas.openxmlformats.org/drawingml/2006/main" xmlns:r="http://schemas.openxmlformats.org/officeDocument/2006/relationships" xmlns:p="http://schemas.openxmlformats.org/presentationml/2006/main">
+  <p:cSld>
+    <p:spTree>
+      <p:nvGrpSpPr>
+        <p:cNvPr id="1" name=""/>
+        <p:cNvGrpSpPr/>
+        <p:nvPr/>
+      </p:nvGrpSpPr>
+      <p:grpSpPr>
+        <a:xfrm>
+          <a:off x="0" y="0"/>
+          <a:ext cx="0" cy="0"/>
+          <a:chOff x="0" y="0"/>
+          <a:chExt cx="0" cy="0"/>
+        </a:xfrm>
+      </p:grpSpPr>
+      <p:sp>
+        <p:nvSpPr>
+          <p:cNvPr id="2" name="Slide Image Placeholder 1"/>
+          <p:cNvSpPr>
+            <a:spLocks noGrp="1" noRot="1" noChangeAspect="1"/>
+          </p:cNvSpPr>
+          <p:nvPr>
+            <p:ph type="sldImg"/>
+          </p:nvPr>
+        </p:nvSpPr>
+        <p:spPr/>
+      </p:sp>
+      <p:sp>
+        <p:nvSpPr>
+          <p:cNvPr id="3" name="Notes Placeholder 2"/>
+          <p:cNvSpPr>
+            <a:spLocks noGrp="1"/>
+          </p:cNvSpPr>
+          <p:nvPr>
+            <p:ph type="body" idx="1"/>
+          </p:nvPr>
+        </p:nvSpPr>
+        <p:spPr/>
+        <p:txBody>
+          <a:bodyPr/>
+          <a:lstStyle/>
+          <a:p>
+            <a:r>
+              <a:rPr lang="en-US" dirty="0"/>
+              <a:t/>
+            </a:r>
+            <a:endParaRPr lang="en-US" dirty="0"/>
+          </a:p>
+        </p:txBody>
+      </p:sp>
+      <p:sp>
+        <p:nvSpPr>
+          <p:cNvPr id="4" name="Slide Number Placeholder 3"/>
+          <p:cNvSpPr>
+            <a:spLocks noGrp="1"/>
+          </p:cNvSpPr>
+          <p:nvPr>
+            <p:ph type="sldNum" sz="quarter" idx="10"/>
+          </p:nvPr>
+        </p:nvSpPr>
+        <p:spPr/>
+        <p:txBody>
+          <a:bodyPr/>
+          <a:lstStyle/>
+          <a:p>
+            <a:fld id="{F7021451-1387-4CA6-816F-3879F97B5CBC}" type="slidenum">
+              <a:rPr lang="en-US"/>
+              <a:t>12</a:t>
+            </a:fld>
+            <a:endParaRPr lang="en-US"/>
+          </a:p>
+        </p:txBody>
+      </p:sp>
+    </p:spTree>
+    <p:extLst>
+      <p:ext uri="{BB962C8B-B14F-4D97-AF65-F5344CB8AC3E}">
+        <p14:creationId xmlns:p14="http://schemas.microsoft.com/office/powerpoint/2010/main" val="1024086991"/>
+      </p:ext>
+    </p:extLst>
+  </p:cSld>
+  <p:clrMapOvr>
+    <a:masterClrMapping/>
+  </p:clrMapOvr>
+</p:notes>
+</file>
+
+<file path=ppt/notesSlides/notesSlide13.xml><?xml version="1.0" encoding="utf-8"?>
+<p:notes xmlns:a="http://schemas.openxmlformats.org/drawingml/2006/main" xmlns:r="http://schemas.openxmlformats.org/officeDocument/2006/relationships" xmlns:p="http://schemas.openxmlformats.org/presentationml/2006/main">
+  <p:cSld>
+    <p:spTree>
+      <p:nvGrpSpPr>
+        <p:cNvPr id="1" name=""/>
+        <p:cNvGrpSpPr/>
+        <p:nvPr/>
+      </p:nvGrpSpPr>
+      <p:grpSpPr>
+        <a:xfrm>
+          <a:off x="0" y="0"/>
+          <a:ext cx="0" cy="0"/>
+          <a:chOff x="0" y="0"/>
+          <a:chExt cx="0" cy="0"/>
+        </a:xfrm>
+      </p:grpSpPr>
+      <p:sp>
+        <p:nvSpPr>
+          <p:cNvPr id="2" name="Slide Image Placeholder 1"/>
+          <p:cNvSpPr>
+            <a:spLocks noGrp="1" noRot="1" noChangeAspect="1"/>
+          </p:cNvSpPr>
+          <p:nvPr>
+            <p:ph type="sldImg"/>
+          </p:nvPr>
+        </p:nvSpPr>
+        <p:spPr/>
+      </p:sp>
+      <p:sp>
+        <p:nvSpPr>
+          <p:cNvPr id="3" name="Notes Placeholder 2"/>
+          <p:cNvSpPr>
+            <a:spLocks noGrp="1"/>
+          </p:cNvSpPr>
+          <p:nvPr>
+            <p:ph type="body" idx="1"/>
+          </p:nvPr>
+        </p:nvSpPr>
+        <p:spPr/>
+        <p:txBody>
+          <a:bodyPr/>
+          <a:lstStyle/>
+          <a:p>
+            <a:r>
+              <a:rPr lang="en-US" dirty="0"/>
+              <a:t/>
+            </a:r>
+            <a:endParaRPr lang="en-US" dirty="0"/>
+          </a:p>
+        </p:txBody>
+      </p:sp>
+      <p:sp>
+        <p:nvSpPr>
+          <p:cNvPr id="4" name="Slide Number Placeholder 3"/>
+          <p:cNvSpPr>
+            <a:spLocks noGrp="1"/>
+          </p:cNvSpPr>
+          <p:nvPr>
+            <p:ph type="sldNum" sz="quarter" idx="10"/>
+          </p:nvPr>
+        </p:nvSpPr>
+        <p:spPr/>
+        <p:txBody>
+          <a:bodyPr/>
+          <a:lstStyle/>
+          <a:p>
+            <a:fld id="{F7021451-1387-4CA6-816F-3879F97B5CBC}" type="slidenum">
+              <a:rPr lang="en-US"/>
+              <a:t>13</a:t>
+            </a:fld>
+            <a:endParaRPr lang="en-US"/>
+          </a:p>
+        </p:txBody>
+      </p:sp>
+    </p:spTree>
+    <p:extLst>
+      <p:ext uri="{BB962C8B-B14F-4D97-AF65-F5344CB8AC3E}">
+        <p14:creationId xmlns:p14="http://schemas.microsoft.com/office/powerpoint/2010/main" val="1024086991"/>
+      </p:ext>
+    </p:extLst>
+  </p:cSld>
+  <p:clrMapOvr>
+    <a:masterClrMapping/>
+  </p:clrMapOvr>
+</p:notes>
+</file>
+
+<file path=ppt/notesSlides/notesSlide14.xml><?xml version="1.0" encoding="utf-8"?>
+<p:notes xmlns:a="http://schemas.openxmlformats.org/drawingml/2006/main" xmlns:r="http://schemas.openxmlformats.org/officeDocument/2006/relationships" xmlns:p="http://schemas.openxmlformats.org/presentationml/2006/main">
+  <p:cSld>
+    <p:spTree>
+      <p:nvGrpSpPr>
+        <p:cNvPr id="1" name=""/>
+        <p:cNvGrpSpPr/>
+        <p:nvPr/>
+      </p:nvGrpSpPr>
+      <p:grpSpPr>
+        <a:xfrm>
+          <a:off x="0" y="0"/>
+          <a:ext cx="0" cy="0"/>
+          <a:chOff x="0" y="0"/>
+          <a:chExt cx="0" cy="0"/>
+        </a:xfrm>
+      </p:grpSpPr>
+      <p:sp>
+        <p:nvSpPr>
+          <p:cNvPr id="2" name="Slide Image Placeholder 1"/>
+          <p:cNvSpPr>
+            <a:spLocks noGrp="1" noRot="1" noChangeAspect="1"/>
+          </p:cNvSpPr>
+          <p:nvPr>
+            <p:ph type="sldImg"/>
+          </p:nvPr>
+        </p:nvSpPr>
+        <p:spPr/>
+      </p:sp>
+      <p:sp>
+        <p:nvSpPr>
+          <p:cNvPr id="3" name="Notes Placeholder 2"/>
+          <p:cNvSpPr>
+            <a:spLocks noGrp="1"/>
+          </p:cNvSpPr>
+          <p:nvPr>
+            <p:ph type="body" idx="1"/>
+          </p:nvPr>
+        </p:nvSpPr>
+        <p:spPr/>
+        <p:txBody>
+          <a:bodyPr/>
+          <a:lstStyle/>
+          <a:p>
+            <a:r>
+              <a:rPr lang="en-US" dirty="0"/>
+              <a:t/>
+            </a:r>
+            <a:endParaRPr lang="en-US" dirty="0"/>
+          </a:p>
+        </p:txBody>
+      </p:sp>
+      <p:sp>
+        <p:nvSpPr>
+          <p:cNvPr id="4" name="Slide Number Placeholder 3"/>
+          <p:cNvSpPr>
+            <a:spLocks noGrp="1"/>
+          </p:cNvSpPr>
+          <p:nvPr>
+            <p:ph type="sldNum" sz="quarter" idx="10"/>
+          </p:nvPr>
+        </p:nvSpPr>
+        <p:spPr/>
+        <p:txBody>
+          <a:bodyPr/>
+          <a:lstStyle/>
+          <a:p>
+            <a:fld id="{F7021451-1387-4CA6-816F-3879F97B5CBC}" type="slidenum">
+              <a:rPr lang="en-US"/>
+              <a:t>14</a:t>
+            </a:fld>
+            <a:endParaRPr lang="en-US"/>
+          </a:p>
+        </p:txBody>
+      </p:sp>
+    </p:spTree>
+    <p:extLst>
+      <p:ext uri="{BB962C8B-B14F-4D97-AF65-F5344CB8AC3E}">
+        <p14:creationId xmlns:p14="http://schemas.microsoft.com/office/powerpoint/2010/main" val="1024086991"/>
+      </p:ext>
+    </p:extLst>
+  </p:cSld>
+  <p:clrMapOvr>
+    <a:masterClrMapping/>
+  </p:clrMapOvr>
+</p:notes>
+</file>
+
+<file path=ppt/notesSlides/notesSlide15.xml><?xml version="1.0" encoding="utf-8"?>
+<p:notes xmlns:a="http://schemas.openxmlformats.org/drawingml/2006/main" xmlns:r="http://schemas.openxmlformats.org/officeDocument/2006/relationships" xmlns:p="http://schemas.openxmlformats.org/presentationml/2006/main">
+  <p:cSld>
+    <p:spTree>
+      <p:nvGrpSpPr>
+        <p:cNvPr id="1" name=""/>
+        <p:cNvGrpSpPr/>
+        <p:nvPr/>
+      </p:nvGrpSpPr>
+      <p:grpSpPr>
+        <a:xfrm>
+          <a:off x="0" y="0"/>
+          <a:ext cx="0" cy="0"/>
+          <a:chOff x="0" y="0"/>
+          <a:chExt cx="0" cy="0"/>
+        </a:xfrm>
+      </p:grpSpPr>
+      <p:sp>
+        <p:nvSpPr>
+          <p:cNvPr id="2" name="Slide Image Placeholder 1"/>
+          <p:cNvSpPr>
+            <a:spLocks noGrp="1" noRot="1" noChangeAspect="1"/>
+          </p:cNvSpPr>
+          <p:nvPr>
+            <p:ph type="sldImg"/>
+          </p:nvPr>
+        </p:nvSpPr>
+        <p:spPr/>
+      </p:sp>
+      <p:sp>
+        <p:nvSpPr>
+          <p:cNvPr id="3" name="Notes Placeholder 2"/>
+          <p:cNvSpPr>
+            <a:spLocks noGrp="1"/>
+          </p:cNvSpPr>
+          <p:nvPr>
+            <p:ph type="body" idx="1"/>
+          </p:nvPr>
+        </p:nvSpPr>
+        <p:spPr/>
+        <p:txBody>
+          <a:bodyPr/>
+          <a:lstStyle/>
+          <a:p>
+            <a:r>
+              <a:rPr lang="en-US" dirty="0"/>
+              <a:t/>
+            </a:r>
+            <a:endParaRPr lang="en-US" dirty="0"/>
+          </a:p>
+        </p:txBody>
+      </p:sp>
+      <p:sp>
+        <p:nvSpPr>
+          <p:cNvPr id="4" name="Slide Number Placeholder 3"/>
+          <p:cNvSpPr>
+            <a:spLocks noGrp="1"/>
+          </p:cNvSpPr>
+          <p:nvPr>
+            <p:ph type="sldNum" sz="quarter" idx="10"/>
+          </p:nvPr>
+        </p:nvSpPr>
+        <p:spPr/>
+        <p:txBody>
+          <a:bodyPr/>
+          <a:lstStyle/>
+          <a:p>
+            <a:fld id="{F7021451-1387-4CA6-816F-3879F97B5CBC}" type="slidenum">
+              <a:rPr lang="en-US"/>
+              <a:t>15</a:t>
             </a:fld>
             <a:endParaRPr lang="en-US"/>
           </a:p>
@@ -2066,7 +2422,7 @@
     <p:bg>
       <p:bgPr>
         <a:solidFill>
-          <a:srgbClr val="2F3C7E"/>
+          <a:srgbClr val="FFF9F0"/>
         </a:solidFill>
       </p:bgPr>
     </p:bg>
@@ -2086,38 +2442,126 @@
       </p:grpSpPr>
       <p:sp>
         <p:nvSpPr>
-          <p:cNvPr id="2" name="Shape 0"/>
-          <p:cNvSpPr/>
-          <p:nvPr/>
-        </p:nvSpPr>
-        <p:spPr>
-          <a:xfrm>
-            <a:off x="7863840" y="3931920"/>
-            <a:ext cx="2377440" cy="2377440"/>
-          </a:xfrm>
-          <a:prstGeom prst="ellipse">
+          <p:cNvPr id="2" name="Text 0"/>
+          <p:cNvSpPr/>
+          <p:nvPr/>
+        </p:nvSpPr>
+        <p:spPr>
+          <a:xfrm>
+            <a:off x="457200" y="411480"/>
+            <a:ext cx="8229600" cy="548640"/>
+          </a:xfrm>
+          <a:prstGeom prst="rect">
+            <a:avLst/>
+          </a:prstGeom>
+          <a:noFill/>
+          <a:ln/>
+        </p:spPr>
+        <p:txBody>
+          <a:bodyPr wrap="square" lIns="0" tIns="0" rIns="0" bIns="0" rtlCol="0" anchor="ctr"/>
+          <a:lstStyle/>
+          <a:p>
+            <a:pPr indent="0" marL="0">
+              <a:buNone/>
+            </a:pPr>
+            <a:r>
+              <a:rPr lang="en-US" sz="2800" b="1" dirty="0">
+                <a:solidFill>
+                  <a:srgbClr val="2B2118"/>
+                </a:solidFill>
+                <a:latin typeface="Georgia" pitchFamily="34" charset="0"/>
+                <a:ea typeface="Georgia" pitchFamily="34" charset="-122"/>
+                <a:cs typeface="Georgia" pitchFamily="34" charset="-120"/>
+              </a:rPr>
+              <a:t>Divide and Conquer Your Work</a:t>
+            </a:r>
+            <a:endParaRPr lang="en-US" sz="2800" dirty="0"/>
+          </a:p>
+        </p:txBody>
+      </p:sp>
+      <p:sp>
+        <p:nvSpPr>
+          <p:cNvPr id="3" name="Text 1"/>
+          <p:cNvSpPr/>
+          <p:nvPr/>
+        </p:nvSpPr>
+        <p:spPr>
+          <a:xfrm>
+            <a:off x="457200" y="960120"/>
+            <a:ext cx="8229600" cy="365760"/>
+          </a:xfrm>
+          <a:prstGeom prst="rect">
+            <a:avLst/>
+          </a:prstGeom>
+          <a:noFill/>
+          <a:ln/>
+        </p:spPr>
+        <p:txBody>
+          <a:bodyPr wrap="square" lIns="0" tIns="0" rIns="0" bIns="0" rtlCol="0" anchor="ctr"/>
+          <a:lstStyle/>
+          <a:p>
+            <a:pPr indent="0" marL="0">
+              <a:buNone/>
+            </a:pPr>
+            <a:r>
+              <a:rPr lang="en-US" sz="1400" i="1" dirty="0">
+                <a:solidFill>
+                  <a:srgbClr val="6B6055"/>
+                </a:solidFill>
+                <a:latin typeface="Calibri" pitchFamily="34" charset="0"/>
+                <a:ea typeface="Calibri" pitchFamily="34" charset="-122"/>
+                <a:cs typeface="Calibri" pitchFamily="34" charset="-120"/>
+              </a:rPr>
+              <a:t>Research → Plan → Implement, in three separate terminals</a:t>
+            </a:r>
+            <a:endParaRPr lang="en-US" sz="1400" dirty="0"/>
+          </a:p>
+        </p:txBody>
+      </p:sp>
+      <p:sp>
+        <p:nvSpPr>
+          <p:cNvPr id="4" name="Shape 2"/>
+          <p:cNvSpPr/>
+          <p:nvPr/>
+        </p:nvSpPr>
+        <p:spPr>
+          <a:xfrm>
+            <a:off x="457200" y="1600200"/>
+            <a:ext cx="2560320" cy="2286000"/>
+          </a:xfrm>
+          <a:prstGeom prst="rect">
             <a:avLst/>
           </a:prstGeom>
           <a:solidFill>
-            <a:srgbClr val="F96167">
-              <a:alpha val="16000"/>
-            </a:srgbClr>
+            <a:srgbClr val="FFFFFF"/>
           </a:solidFill>
-          <a:ln/>
-        </p:spPr>
-      </p:sp>
-      <p:sp>
-        <p:nvSpPr>
-          <p:cNvPr id="3" name="Shape 1"/>
-          <p:cNvSpPr/>
-          <p:nvPr/>
-        </p:nvSpPr>
-        <p:spPr>
-          <a:xfrm>
-            <a:off x="548640" y="502920"/>
-            <a:ext cx="868680" cy="868680"/>
-          </a:xfrm>
-          <a:prstGeom prst="ellipse">
+          <a:ln w="12700">
+            <a:solidFill>
+              <a:srgbClr val="EFE3D3"/>
+            </a:solidFill>
+            <a:prstDash val="solid"/>
+          </a:ln>
+          <a:effectLst>
+            <a:outerShdw sx="100000" sy="100000" kx="0" ky="0" algn="bl" rotWithShape="0" blurRad="76200" dist="25400" dir="8100000">
+              <a:srgbClr val="000000">
+                <a:alpha val="10000"/>
+              </a:srgbClr>
+            </a:outerShdw>
+          </a:effectLst>
+        </p:spPr>
+      </p:sp>
+      <p:sp>
+        <p:nvSpPr>
+          <p:cNvPr id="5" name="Shape 3"/>
+          <p:cNvSpPr/>
+          <p:nvPr/>
+        </p:nvSpPr>
+        <p:spPr>
+          <a:xfrm>
+            <a:off x="457200" y="1600200"/>
+            <a:ext cx="2560320" cy="109728"/>
+          </a:xfrm>
+          <a:prstGeom prst="rect">
             <a:avLst/>
           </a:prstGeom>
           <a:solidFill>
@@ -2126,40 +2570,16 @@
           <a:ln/>
         </p:spPr>
       </p:sp>
-      <p:pic>
-        <p:nvPicPr>
-          <p:cNvPr id="4" name="Image 0" descr="preencoded.png">    </p:cNvPr>
-          <p:cNvPicPr>
-            <a:picLocks noChangeAspect="1"/>
-          </p:cNvPicPr>
-          <p:nvPr/>
-        </p:nvPicPr>
-        <p:blipFill>
-          <a:blip r:embed="rId1"/>
-          <a:stretch>
-            <a:fillRect/>
-          </a:stretch>
-        </p:blipFill>
-        <p:spPr>
-          <a:xfrm>
-            <a:off x="644195" y="598475"/>
-            <a:ext cx="677570" cy="677570"/>
-          </a:xfrm>
-          <a:prstGeom prst="rect">
-            <a:avLst/>
-          </a:prstGeom>
-        </p:spPr>
-      </p:pic>
-      <p:sp>
-        <p:nvSpPr>
-          <p:cNvPr id="5" name="Text 2"/>
-          <p:cNvSpPr/>
-          <p:nvPr/>
-        </p:nvSpPr>
-        <p:spPr>
-          <a:xfrm>
-            <a:off x="1600200" y="566928"/>
-            <a:ext cx="3657600" cy="365760"/>
+      <p:sp>
+        <p:nvSpPr>
+          <p:cNvPr id="6" name="Text 4"/>
+          <p:cNvSpPr/>
+          <p:nvPr/>
+        </p:nvSpPr>
+        <p:spPr>
+          <a:xfrm>
+            <a:off x="640080" y="1828800"/>
+            <a:ext cx="2194560" cy="274320"/>
           </a:xfrm>
           <a:prstGeom prst="rect">
             <a:avLst/>
@@ -2175,30 +2595,30 @@
               <a:buNone/>
             </a:pPr>
             <a:r>
-              <a:rPr lang="en-US" sz="1300" b="1" spc="200" kern="0" dirty="0">
-                <a:solidFill>
-                  <a:srgbClr val="F9E795"/>
+              <a:rPr lang="en-US" sz="1100" b="1" dirty="0">
+                <a:solidFill>
+                  <a:srgbClr val="6B6055"/>
                 </a:solidFill>
                 <a:latin typeface="Consolas" pitchFamily="34" charset="0"/>
                 <a:ea typeface="Consolas" pitchFamily="34" charset="-122"/>
                 <a:cs typeface="Consolas" pitchFamily="34" charset="-120"/>
               </a:rPr>
-              <a:t>BONUS · BUDGET</a:t>
-            </a:r>
-            <a:endParaRPr lang="en-US" sz="1300" dirty="0"/>
-          </a:p>
-        </p:txBody>
-      </p:sp>
-      <p:sp>
-        <p:nvSpPr>
-          <p:cNvPr id="6" name="Text 3"/>
-          <p:cNvSpPr/>
-          <p:nvPr/>
-        </p:nvSpPr>
-        <p:spPr>
-          <a:xfrm>
-            <a:off x="548640" y="1234440"/>
-            <a:ext cx="8046720" cy="822960"/>
+              <a:t>Terminal 1</a:t>
+            </a:r>
+            <a:endParaRPr lang="en-US" sz="1100" dirty="0"/>
+          </a:p>
+        </p:txBody>
+      </p:sp>
+      <p:sp>
+        <p:nvSpPr>
+          <p:cNvPr id="7" name="Text 5"/>
+          <p:cNvSpPr/>
+          <p:nvPr/>
+        </p:nvSpPr>
+        <p:spPr>
+          <a:xfrm>
+            <a:off x="640080" y="2103120"/>
+            <a:ext cx="2194560" cy="457200"/>
           </a:xfrm>
           <a:prstGeom prst="rect">
             <a:avLst/>
@@ -2214,52 +2634,30 @@
               <a:buNone/>
             </a:pPr>
             <a:r>
-              <a:rPr lang="en-US" sz="2600" b="1" dirty="0">
-                <a:solidFill>
-                  <a:srgbClr val="FFFFFF"/>
-                </a:solidFill>
-                <a:latin typeface="Georgia" pitchFamily="34" charset="0"/>
-                <a:ea typeface="Georgia" pitchFamily="34" charset="-122"/>
-                <a:cs typeface="Georgia" pitchFamily="34" charset="-120"/>
-              </a:rPr>
-              <a:t>Keeping the Sprint Sustainable</a:t>
-            </a:r>
-            <a:endParaRPr lang="en-US" sz="2600" dirty="0"/>
-          </a:p>
-        </p:txBody>
-      </p:sp>
-      <p:sp>
-        <p:nvSpPr>
-          <p:cNvPr id="7" name="Shape 4"/>
-          <p:cNvSpPr/>
-          <p:nvPr/>
-        </p:nvSpPr>
-        <p:spPr>
-          <a:xfrm>
-            <a:off x="548640" y="2148840"/>
-            <a:ext cx="8046720" cy="1051560"/>
-          </a:xfrm>
-          <a:prstGeom prst="rect">
-            <a:avLst/>
-          </a:prstGeom>
-          <a:solidFill>
-            <a:srgbClr val="FFFFFF">
-              <a:alpha val="8000"/>
-            </a:srgbClr>
-          </a:solidFill>
-          <a:ln/>
-        </p:spPr>
-      </p:sp>
-      <p:sp>
-        <p:nvSpPr>
-          <p:cNvPr id="8" name="Text 5"/>
-          <p:cNvSpPr/>
-          <p:nvPr/>
-        </p:nvSpPr>
-        <p:spPr>
-          <a:xfrm>
-            <a:off x="822960" y="2240280"/>
-            <a:ext cx="7498080" cy="868680"/>
+              <a:rPr lang="en-US" sz="2000" b="1" dirty="0">
+                <a:solidFill>
+                  <a:srgbClr val="2F3C7E"/>
+                </a:solidFill>
+                <a:latin typeface="Consolas" pitchFamily="34" charset="0"/>
+                <a:ea typeface="Consolas" pitchFamily="34" charset="-122"/>
+                <a:cs typeface="Consolas" pitchFamily="34" charset="-120"/>
+              </a:rPr>
+              <a:t>/research</a:t>
+            </a:r>
+            <a:endParaRPr lang="en-US" sz="2000" dirty="0"/>
+          </a:p>
+        </p:txBody>
+      </p:sp>
+      <p:sp>
+        <p:nvSpPr>
+          <p:cNvPr id="8" name="Text 6"/>
+          <p:cNvSpPr/>
+          <p:nvPr/>
+        </p:nvSpPr>
+        <p:spPr>
+          <a:xfrm>
+            <a:off x="640080" y="2606040"/>
+            <a:ext cx="2194560" cy="1097280"/>
           </a:xfrm>
           <a:prstGeom prst="rect">
             <a:avLst/>
@@ -2275,30 +2673,118 @@
               <a:buNone/>
             </a:pPr>
             <a:r>
-              <a:rPr lang="en-US" sz="1500" i="1" dirty="0">
-                <a:solidFill>
-                  <a:srgbClr val="FFF9F0"/>
+              <a:rPr lang="en-US" sz="1250" dirty="0">
+                <a:solidFill>
+                  <a:srgbClr val="4A4038"/>
                 </a:solidFill>
                 <a:latin typeface="Calibri" pitchFamily="34" charset="0"/>
                 <a:ea typeface="Calibri" pitchFamily="34" charset="-122"/>
                 <a:cs typeface="Calibri" pitchFamily="34" charset="-120"/>
               </a:rPr>
-              <a:t>Before rolling this out org-wide, the team checks seats, usage, and budget alerts in GitHub billing.</a:t>
-            </a:r>
-            <a:endParaRPr lang="en-US" sz="1500" dirty="0"/>
-          </a:p>
-        </p:txBody>
-      </p:sp>
-      <p:sp>
-        <p:nvSpPr>
-          <p:cNvPr id="9" name="Text 6"/>
-          <p:cNvSpPr/>
-          <p:nvPr/>
-        </p:nvSpPr>
-        <p:spPr>
-          <a:xfrm>
-            <a:off x="548640" y="3429000"/>
-            <a:ext cx="8046720" cy="914400"/>
+              <a:t>Investigate &amp; narrow down the approach</a:t>
+            </a:r>
+            <a:endParaRPr lang="en-US" sz="1250" dirty="0"/>
+          </a:p>
+        </p:txBody>
+      </p:sp>
+      <p:sp>
+        <p:nvSpPr>
+          <p:cNvPr id="9" name="Text 7"/>
+          <p:cNvSpPr/>
+          <p:nvPr/>
+        </p:nvSpPr>
+        <p:spPr>
+          <a:xfrm>
+            <a:off x="3017520" y="2377440"/>
+            <a:ext cx="228600" cy="457200"/>
+          </a:xfrm>
+          <a:prstGeom prst="rect">
+            <a:avLst/>
+          </a:prstGeom>
+          <a:noFill/>
+          <a:ln/>
+        </p:spPr>
+        <p:txBody>
+          <a:bodyPr wrap="square" lIns="0" tIns="0" rIns="0" bIns="0" rtlCol="0" anchor="ctr"/>
+          <a:lstStyle/>
+          <a:p>
+            <a:pPr algn="ctr" indent="0" marL="0">
+              <a:buNone/>
+            </a:pPr>
+            <a:r>
+              <a:rPr lang="en-US" sz="2200" b="1" dirty="0">
+                <a:solidFill>
+                  <a:srgbClr val="F96167"/>
+                </a:solidFill>
+              </a:rPr>
+              <a:t>→</a:t>
+            </a:r>
+            <a:endParaRPr lang="en-US" sz="2200" dirty="0"/>
+          </a:p>
+        </p:txBody>
+      </p:sp>
+      <p:sp>
+        <p:nvSpPr>
+          <p:cNvPr id="10" name="Shape 8"/>
+          <p:cNvSpPr/>
+          <p:nvPr/>
+        </p:nvSpPr>
+        <p:spPr>
+          <a:xfrm>
+            <a:off x="3246120" y="1600200"/>
+            <a:ext cx="2560320" cy="2286000"/>
+          </a:xfrm>
+          <a:prstGeom prst="rect">
+            <a:avLst/>
+          </a:prstGeom>
+          <a:solidFill>
+            <a:srgbClr val="FFFFFF"/>
+          </a:solidFill>
+          <a:ln w="12700">
+            <a:solidFill>
+              <a:srgbClr val="EFE3D3"/>
+            </a:solidFill>
+            <a:prstDash val="solid"/>
+          </a:ln>
+          <a:effectLst>
+            <a:outerShdw sx="100000" sy="100000" kx="0" ky="0" algn="bl" rotWithShape="0" blurRad="76200" dist="25400" dir="8100000">
+              <a:srgbClr val="000000">
+                <a:alpha val="10000"/>
+              </a:srgbClr>
+            </a:outerShdw>
+          </a:effectLst>
+        </p:spPr>
+      </p:sp>
+      <p:sp>
+        <p:nvSpPr>
+          <p:cNvPr id="11" name="Shape 9"/>
+          <p:cNvSpPr/>
+          <p:nvPr/>
+        </p:nvSpPr>
+        <p:spPr>
+          <a:xfrm>
+            <a:off x="3246120" y="1600200"/>
+            <a:ext cx="2560320" cy="109728"/>
+          </a:xfrm>
+          <a:prstGeom prst="rect">
+            <a:avLst/>
+          </a:prstGeom>
+          <a:solidFill>
+            <a:srgbClr val="2F3C7E"/>
+          </a:solidFill>
+          <a:ln/>
+        </p:spPr>
+      </p:sp>
+      <p:sp>
+        <p:nvSpPr>
+          <p:cNvPr id="12" name="Text 10"/>
+          <p:cNvSpPr/>
+          <p:nvPr/>
+        </p:nvSpPr>
+        <p:spPr>
+          <a:xfrm>
+            <a:off x="3429000" y="1828800"/>
+            <a:ext cx="2194560" cy="274320"/>
           </a:xfrm>
           <a:prstGeom prst="rect">
             <a:avLst/>
@@ -2314,68 +2800,376 @@
               <a:buNone/>
             </a:pPr>
             <a:r>
-              <a:rPr lang="en-US" sz="1400" b="1" dirty="0">
-                <a:solidFill>
-                  <a:srgbClr val="F9E795"/>
+              <a:rPr lang="en-US" sz="1100" b="1" dirty="0">
+                <a:solidFill>
+                  <a:srgbClr val="6B6055"/>
+                </a:solidFill>
+                <a:latin typeface="Consolas" pitchFamily="34" charset="0"/>
+                <a:ea typeface="Consolas" pitchFamily="34" charset="-122"/>
+                <a:cs typeface="Consolas" pitchFamily="34" charset="-120"/>
+              </a:rPr>
+              <a:t>Terminal 2</a:t>
+            </a:r>
+            <a:endParaRPr lang="en-US" sz="1100" dirty="0"/>
+          </a:p>
+        </p:txBody>
+      </p:sp>
+      <p:sp>
+        <p:nvSpPr>
+          <p:cNvPr id="13" name="Text 11"/>
+          <p:cNvSpPr/>
+          <p:nvPr/>
+        </p:nvSpPr>
+        <p:spPr>
+          <a:xfrm>
+            <a:off x="3429000" y="2103120"/>
+            <a:ext cx="2194560" cy="457200"/>
+          </a:xfrm>
+          <a:prstGeom prst="rect">
+            <a:avLst/>
+          </a:prstGeom>
+          <a:noFill/>
+          <a:ln/>
+        </p:spPr>
+        <p:txBody>
+          <a:bodyPr wrap="square" lIns="0" tIns="0" rIns="0" bIns="0" rtlCol="0" anchor="ctr"/>
+          <a:lstStyle/>
+          <a:p>
+            <a:pPr indent="0" marL="0">
+              <a:buNone/>
+            </a:pPr>
+            <a:r>
+              <a:rPr lang="en-US" sz="2000" b="1" dirty="0">
+                <a:solidFill>
+                  <a:srgbClr val="2F3C7E"/>
+                </a:solidFill>
+                <a:latin typeface="Consolas" pitchFamily="34" charset="0"/>
+                <a:ea typeface="Consolas" pitchFamily="34" charset="-122"/>
+                <a:cs typeface="Consolas" pitchFamily="34" charset="-120"/>
+              </a:rPr>
+              <a:t>/plan</a:t>
+            </a:r>
+            <a:endParaRPr lang="en-US" sz="2000" dirty="0"/>
+          </a:p>
+        </p:txBody>
+      </p:sp>
+      <p:sp>
+        <p:nvSpPr>
+          <p:cNvPr id="14" name="Text 12"/>
+          <p:cNvSpPr/>
+          <p:nvPr/>
+        </p:nvSpPr>
+        <p:spPr>
+          <a:xfrm>
+            <a:off x="3429000" y="2606040"/>
+            <a:ext cx="2194560" cy="1097280"/>
+          </a:xfrm>
+          <a:prstGeom prst="rect">
+            <a:avLst/>
+          </a:prstGeom>
+          <a:noFill/>
+          <a:ln/>
+        </p:spPr>
+        <p:txBody>
+          <a:bodyPr wrap="square" lIns="0" tIns="0" rIns="0" bIns="0" rtlCol="0" anchor="ctr"/>
+          <a:lstStyle/>
+          <a:p>
+            <a:pPr indent="0" marL="0">
+              <a:buNone/>
+            </a:pPr>
+            <a:r>
+              <a:rPr lang="en-US" sz="1250" dirty="0">
+                <a:solidFill>
+                  <a:srgbClr val="4A4038"/>
                 </a:solidFill>
                 <a:latin typeface="Calibri" pitchFamily="34" charset="0"/>
                 <a:ea typeface="Calibri" pitchFamily="34" charset="-122"/>
                 <a:cs typeface="Calibri" pitchFamily="34" charset="-120"/>
               </a:rPr>
-              <a:t>Try it: </a:t>
-            </a:r>
+              <a:t>Turn findings into a precise spec</a:t>
+            </a:r>
+            <a:endParaRPr lang="en-US" sz="1250" dirty="0"/>
+          </a:p>
+        </p:txBody>
+      </p:sp>
+      <p:sp>
+        <p:nvSpPr>
+          <p:cNvPr id="15" name="Text 13"/>
+          <p:cNvSpPr/>
+          <p:nvPr/>
+        </p:nvSpPr>
+        <p:spPr>
+          <a:xfrm>
+            <a:off x="5806440" y="2377440"/>
+            <a:ext cx="228600" cy="457200"/>
+          </a:xfrm>
+          <a:prstGeom prst="rect">
+            <a:avLst/>
+          </a:prstGeom>
+          <a:noFill/>
+          <a:ln/>
+        </p:spPr>
+        <p:txBody>
+          <a:bodyPr wrap="square" lIns="0" tIns="0" rIns="0" bIns="0" rtlCol="0" anchor="ctr"/>
+          <a:lstStyle/>
+          <a:p>
+            <a:pPr algn="ctr" indent="0" marL="0">
+              <a:buNone/>
+            </a:pPr>
+            <a:r>
+              <a:rPr lang="en-US" sz="2200" b="1" dirty="0">
+                <a:solidFill>
+                  <a:srgbClr val="F96167"/>
+                </a:solidFill>
+              </a:rPr>
+              <a:t>→</a:t>
+            </a:r>
+            <a:endParaRPr lang="en-US" sz="2200" dirty="0"/>
+          </a:p>
+        </p:txBody>
+      </p:sp>
+      <p:sp>
+        <p:nvSpPr>
+          <p:cNvPr id="16" name="Shape 14"/>
+          <p:cNvSpPr/>
+          <p:nvPr/>
+        </p:nvSpPr>
+        <p:spPr>
+          <a:xfrm>
+            <a:off x="6035040" y="1600200"/>
+            <a:ext cx="2560320" cy="2286000"/>
+          </a:xfrm>
+          <a:prstGeom prst="rect">
+            <a:avLst/>
+          </a:prstGeom>
+          <a:solidFill>
+            <a:srgbClr val="FFFFFF"/>
+          </a:solidFill>
+          <a:ln w="12700">
+            <a:solidFill>
+              <a:srgbClr val="EFE3D3"/>
+            </a:solidFill>
+            <a:prstDash val="solid"/>
+          </a:ln>
+          <a:effectLst>
+            <a:outerShdw sx="100000" sy="100000" kx="0" ky="0" algn="bl" rotWithShape="0" blurRad="76200" dist="25400" dir="8100000">
+              <a:srgbClr val="000000">
+                <a:alpha val="10000"/>
+              </a:srgbClr>
+            </a:outerShdw>
+          </a:effectLst>
+        </p:spPr>
+      </p:sp>
+      <p:sp>
+        <p:nvSpPr>
+          <p:cNvPr id="17" name="Shape 15"/>
+          <p:cNvSpPr/>
+          <p:nvPr/>
+        </p:nvSpPr>
+        <p:spPr>
+          <a:xfrm>
+            <a:off x="6035040" y="1600200"/>
+            <a:ext cx="2560320" cy="109728"/>
+          </a:xfrm>
+          <a:prstGeom prst="rect">
+            <a:avLst/>
+          </a:prstGeom>
+          <a:solidFill>
+            <a:srgbClr val="F9E795"/>
+          </a:solidFill>
+          <a:ln/>
+        </p:spPr>
+      </p:sp>
+      <p:sp>
+        <p:nvSpPr>
+          <p:cNvPr id="18" name="Text 16"/>
+          <p:cNvSpPr/>
+          <p:nvPr/>
+        </p:nvSpPr>
+        <p:spPr>
+          <a:xfrm>
+            <a:off x="6217920" y="1828800"/>
+            <a:ext cx="2194560" cy="274320"/>
+          </a:xfrm>
+          <a:prstGeom prst="rect">
+            <a:avLst/>
+          </a:prstGeom>
+          <a:noFill/>
+          <a:ln/>
+        </p:spPr>
+        <p:txBody>
+          <a:bodyPr wrap="square" lIns="0" tIns="0" rIns="0" bIns="0" rtlCol="0" anchor="ctr"/>
+          <a:lstStyle/>
+          <a:p>
             <a:pPr indent="0" marL="0">
               <a:buNone/>
             </a:pPr>
             <a:r>
-              <a:rPr lang="en-US" sz="1400" dirty="0">
-                <a:solidFill>
-                  <a:srgbClr val="FFFFFF"/>
+              <a:rPr lang="en-US" sz="1100" b="1" dirty="0">
+                <a:solidFill>
+                  <a:srgbClr val="6B6055"/>
+                </a:solidFill>
+                <a:latin typeface="Consolas" pitchFamily="34" charset="0"/>
+                <a:ea typeface="Consolas" pitchFamily="34" charset="-122"/>
+                <a:cs typeface="Consolas" pitchFamily="34" charset="-120"/>
+              </a:rPr>
+              <a:t>Terminal 3</a:t>
+            </a:r>
+            <a:endParaRPr lang="en-US" sz="1100" dirty="0"/>
+          </a:p>
+        </p:txBody>
+      </p:sp>
+      <p:sp>
+        <p:nvSpPr>
+          <p:cNvPr id="19" name="Text 17"/>
+          <p:cNvSpPr/>
+          <p:nvPr/>
+        </p:nvSpPr>
+        <p:spPr>
+          <a:xfrm>
+            <a:off x="6217920" y="2103120"/>
+            <a:ext cx="2194560" cy="457200"/>
+          </a:xfrm>
+          <a:prstGeom prst="rect">
+            <a:avLst/>
+          </a:prstGeom>
+          <a:noFill/>
+          <a:ln/>
+        </p:spPr>
+        <p:txBody>
+          <a:bodyPr wrap="square" lIns="0" tIns="0" rIns="0" bIns="0" rtlCol="0" anchor="ctr"/>
+          <a:lstStyle/>
+          <a:p>
+            <a:pPr indent="0" marL="0">
+              <a:buNone/>
+            </a:pPr>
+            <a:r>
+              <a:rPr lang="en-US" sz="2000" b="1" dirty="0">
+                <a:solidFill>
+                  <a:srgbClr val="2F3C7E"/>
+                </a:solidFill>
+                <a:latin typeface="Consolas" pitchFamily="34" charset="0"/>
+                <a:ea typeface="Consolas" pitchFamily="34" charset="-122"/>
+                <a:cs typeface="Consolas" pitchFamily="34" charset="-120"/>
+              </a:rPr>
+              <a:t>/fleet</a:t>
+            </a:r>
+            <a:endParaRPr lang="en-US" sz="2000" dirty="0"/>
+          </a:p>
+        </p:txBody>
+      </p:sp>
+      <p:sp>
+        <p:nvSpPr>
+          <p:cNvPr id="20" name="Text 18"/>
+          <p:cNvSpPr/>
+          <p:nvPr/>
+        </p:nvSpPr>
+        <p:spPr>
+          <a:xfrm>
+            <a:off x="6217920" y="2606040"/>
+            <a:ext cx="2194560" cy="1097280"/>
+          </a:xfrm>
+          <a:prstGeom prst="rect">
+            <a:avLst/>
+          </a:prstGeom>
+          <a:noFill/>
+          <a:ln/>
+        </p:spPr>
+        <p:txBody>
+          <a:bodyPr wrap="square" lIns="0" tIns="0" rIns="0" bIns="0" rtlCol="0" anchor="ctr"/>
+          <a:lstStyle/>
+          <a:p>
+            <a:pPr indent="0" marL="0">
+              <a:buNone/>
+            </a:pPr>
+            <a:r>
+              <a:rPr lang="en-US" sz="1250" dirty="0">
+                <a:solidFill>
+                  <a:srgbClr val="4A4038"/>
                 </a:solidFill>
                 <a:latin typeface="Calibri" pitchFamily="34" charset="0"/>
                 <a:ea typeface="Calibri" pitchFamily="34" charset="-122"/>
                 <a:cs typeface="Calibri" pitchFamily="34" charset="-120"/>
               </a:rPr>
-              <a:t>Find your Copilot usage in Settings → Billing, and guess your monthly spend before you look.</a:t>
-            </a:r>
-            <a:endParaRPr lang="en-US" sz="1400" dirty="0"/>
-          </a:p>
-        </p:txBody>
-      </p:sp>
-      <p:sp>
-        <p:nvSpPr>
-          <p:cNvPr id="10" name="Text 7"/>
-          <p:cNvSpPr/>
-          <p:nvPr/>
-        </p:nvSpPr>
-        <p:spPr>
-          <a:xfrm>
-            <a:off x="548640" y="4709160"/>
-            <a:ext cx="8046720" cy="274320"/>
-          </a:xfrm>
-          <a:prstGeom prst="rect">
-            <a:avLst/>
-          </a:prstGeom>
-          <a:noFill/>
-          <a:ln/>
-        </p:spPr>
-        <p:txBody>
-          <a:bodyPr wrap="square" lIns="0" tIns="0" rIns="0" bIns="0" rtlCol="0" anchor="ctr"/>
-          <a:lstStyle/>
-          <a:p>
-            <a:pPr algn="l" indent="0" marL="0">
-              <a:buNone/>
-            </a:pPr>
-            <a:r>
-              <a:rPr lang="en-US" sz="1000" dirty="0">
-                <a:solidFill>
-                  <a:srgbClr val="9BA6D6"/>
+              <a:t>Implement in parallel workstreams</a:t>
+            </a:r>
+            <a:endParaRPr lang="en-US" sz="1250" dirty="0"/>
+          </a:p>
+        </p:txBody>
+      </p:sp>
+      <p:sp>
+        <p:nvSpPr>
+          <p:cNvPr id="21" name="Text 19"/>
+          <p:cNvSpPr/>
+          <p:nvPr/>
+        </p:nvSpPr>
+        <p:spPr>
+          <a:xfrm>
+            <a:off x="457200" y="4114800"/>
+            <a:ext cx="8229600" cy="548640"/>
+          </a:xfrm>
+          <a:prstGeom prst="rect">
+            <a:avLst/>
+          </a:prstGeom>
+          <a:noFill/>
+          <a:ln/>
+        </p:spPr>
+        <p:txBody>
+          <a:bodyPr wrap="square" lIns="0" tIns="0" rIns="0" bIns="0" rtlCol="0" anchor="ctr"/>
+          <a:lstStyle/>
+          <a:p>
+            <a:pPr indent="0" marL="0">
+              <a:buNone/>
+            </a:pPr>
+            <a:r>
+              <a:rPr lang="en-US" sz="1300" dirty="0">
+                <a:solidFill>
+                  <a:srgbClr val="2F3C7E"/>
                 </a:solidFill>
                 <a:latin typeface="Calibri" pitchFamily="34" charset="0"/>
                 <a:ea typeface="Calibri" pitchFamily="34" charset="-122"/>
                 <a:cs typeface="Calibri" pitchFamily="34" charset="-120"/>
               </a:rPr>
-              <a:t>copilot-cli-lab · bonus · budget</a:t>
+              <a:t>Each stage hands the next a distilled summary - not its full context. Three lean sessions beat one session paying for everything, stacked.</a:t>
+            </a:r>
+            <a:endParaRPr lang="en-US" sz="1300" dirty="0"/>
+          </a:p>
+        </p:txBody>
+      </p:sp>
+      <p:sp>
+        <p:nvSpPr>
+          <p:cNvPr id="22" name="Text 20"/>
+          <p:cNvSpPr/>
+          <p:nvPr/>
+        </p:nvSpPr>
+        <p:spPr>
+          <a:xfrm>
+            <a:off x="548640" y="4709160"/>
+            <a:ext cx="8046720" cy="274320"/>
+          </a:xfrm>
+          <a:prstGeom prst="rect">
+            <a:avLst/>
+          </a:prstGeom>
+          <a:noFill/>
+          <a:ln/>
+        </p:spPr>
+        <p:txBody>
+          <a:bodyPr wrap="square" lIns="0" tIns="0" rIns="0" bIns="0" rtlCol="0" anchor="ctr"/>
+          <a:lstStyle/>
+          <a:p>
+            <a:pPr algn="l" indent="0" marL="0">
+              <a:buNone/>
+            </a:pPr>
+            <a:r>
+              <a:rPr lang="en-US" sz="1000" dirty="0">
+                <a:solidFill>
+                  <a:srgbClr val="B5A78F"/>
+                </a:solidFill>
+                <a:latin typeface="Calibri" pitchFamily="34" charset="0"/>
+                <a:ea typeface="Calibri" pitchFamily="34" charset="-122"/>
+                <a:cs typeface="Calibri" pitchFamily="34" charset="-120"/>
+              </a:rPr>
+              <a:t>copilot-cli-lab · concept</a:t>
             </a:r>
             <a:endParaRPr lang="en-US" sz="1000" dirty="0"/>
           </a:p>
@@ -2421,6 +3215,1625 @@
         </p:nvSpPr>
         <p:spPr>
           <a:xfrm>
+            <a:off x="7863840" y="3931920"/>
+            <a:ext cx="2377440" cy="2377440"/>
+          </a:xfrm>
+          <a:prstGeom prst="ellipse">
+            <a:avLst/>
+          </a:prstGeom>
+          <a:solidFill>
+            <a:srgbClr val="F96167">
+              <a:alpha val="16000"/>
+            </a:srgbClr>
+          </a:solidFill>
+          <a:ln/>
+        </p:spPr>
+      </p:sp>
+      <p:sp>
+        <p:nvSpPr>
+          <p:cNvPr id="3" name="Shape 1"/>
+          <p:cNvSpPr/>
+          <p:nvPr/>
+        </p:nvSpPr>
+        <p:spPr>
+          <a:xfrm>
+            <a:off x="548640" y="502920"/>
+            <a:ext cx="868680" cy="868680"/>
+          </a:xfrm>
+          <a:prstGeom prst="ellipse">
+            <a:avLst/>
+          </a:prstGeom>
+          <a:solidFill>
+            <a:srgbClr val="F96167"/>
+          </a:solidFill>
+          <a:ln/>
+        </p:spPr>
+      </p:sp>
+      <p:pic>
+        <p:nvPicPr>
+          <p:cNvPr id="4" name="Image 0" descr="preencoded.png">    </p:cNvPr>
+          <p:cNvPicPr>
+            <a:picLocks noChangeAspect="1"/>
+          </p:cNvPicPr>
+          <p:nvPr/>
+        </p:nvPicPr>
+        <p:blipFill>
+          <a:blip r:embed="rId1"/>
+          <a:stretch>
+            <a:fillRect/>
+          </a:stretch>
+        </p:blipFill>
+        <p:spPr>
+          <a:xfrm>
+            <a:off x="644195" y="598475"/>
+            <a:ext cx="677570" cy="677570"/>
+          </a:xfrm>
+          <a:prstGeom prst="rect">
+            <a:avLst/>
+          </a:prstGeom>
+        </p:spPr>
+      </p:pic>
+      <p:sp>
+        <p:nvSpPr>
+          <p:cNvPr id="5" name="Text 2"/>
+          <p:cNvSpPr/>
+          <p:nvPr/>
+        </p:nvSpPr>
+        <p:spPr>
+          <a:xfrm>
+            <a:off x="1600200" y="566928"/>
+            <a:ext cx="3657600" cy="365760"/>
+          </a:xfrm>
+          <a:prstGeom prst="rect">
+            <a:avLst/>
+          </a:prstGeom>
+          <a:noFill/>
+          <a:ln/>
+        </p:spPr>
+        <p:txBody>
+          <a:bodyPr wrap="square" lIns="0" tIns="0" rIns="0" bIns="0" rtlCol="0" anchor="ctr"/>
+          <a:lstStyle/>
+          <a:p>
+            <a:pPr indent="0" marL="0">
+              <a:buNone/>
+            </a:pPr>
+            <a:r>
+              <a:rPr lang="en-US" sz="1300" b="1" spc="200" kern="0" dirty="0">
+                <a:solidFill>
+                  <a:srgbClr val="F9E795"/>
+                </a:solidFill>
+                <a:latin typeface="Consolas" pitchFamily="34" charset="0"/>
+                <a:ea typeface="Consolas" pitchFamily="34" charset="-122"/>
+                <a:cs typeface="Consolas" pitchFamily="34" charset="-120"/>
+              </a:rPr>
+              <a:t>DAY 5 · AUTOMATE</a:t>
+            </a:r>
+            <a:endParaRPr lang="en-US" sz="1300" dirty="0"/>
+          </a:p>
+        </p:txBody>
+      </p:sp>
+      <p:sp>
+        <p:nvSpPr>
+          <p:cNvPr id="6" name="Text 3"/>
+          <p:cNvSpPr/>
+          <p:nvPr/>
+        </p:nvSpPr>
+        <p:spPr>
+          <a:xfrm>
+            <a:off x="548640" y="1234440"/>
+            <a:ext cx="8046720" cy="822960"/>
+          </a:xfrm>
+          <a:prstGeom prst="rect">
+            <a:avLst/>
+          </a:prstGeom>
+          <a:noFill/>
+          <a:ln/>
+        </p:spPr>
+        <p:txBody>
+          <a:bodyPr wrap="square" lIns="0" tIns="0" rIns="0" bIns="0" rtlCol="0" anchor="ctr"/>
+          <a:lstStyle/>
+          <a:p>
+            <a:pPr indent="0" marL="0">
+              <a:buNone/>
+            </a:pPr>
+            <a:r>
+              <a:rPr lang="en-US" sz="2600" b="1" dirty="0">
+                <a:solidFill>
+                  <a:srgbClr val="FFFFFF"/>
+                </a:solidFill>
+                <a:latin typeface="Georgia" pitchFamily="34" charset="0"/>
+                <a:ea typeface="Georgia" pitchFamily="34" charset="-122"/>
+                <a:cs typeface="Georgia" pitchFamily="34" charset="-120"/>
+              </a:rPr>
+              <a:t>Automating the Busywork</a:t>
+            </a:r>
+            <a:endParaRPr lang="en-US" sz="2600" dirty="0"/>
+          </a:p>
+        </p:txBody>
+      </p:sp>
+      <p:sp>
+        <p:nvSpPr>
+          <p:cNvPr id="7" name="Shape 4"/>
+          <p:cNvSpPr/>
+          <p:nvPr/>
+        </p:nvSpPr>
+        <p:spPr>
+          <a:xfrm>
+            <a:off x="548640" y="2148840"/>
+            <a:ext cx="8046720" cy="1051560"/>
+          </a:xfrm>
+          <a:prstGeom prst="rect">
+            <a:avLst/>
+          </a:prstGeom>
+          <a:solidFill>
+            <a:srgbClr val="FFFFFF">
+              <a:alpha val="8000"/>
+            </a:srgbClr>
+          </a:solidFill>
+          <a:ln/>
+        </p:spPr>
+      </p:sp>
+      <p:sp>
+        <p:nvSpPr>
+          <p:cNvPr id="8" name="Text 5"/>
+          <p:cNvSpPr/>
+          <p:nvPr/>
+        </p:nvSpPr>
+        <p:spPr>
+          <a:xfrm>
+            <a:off x="822960" y="2240280"/>
+            <a:ext cx="7498080" cy="868680"/>
+          </a:xfrm>
+          <a:prstGeom prst="rect">
+            <a:avLst/>
+          </a:prstGeom>
+          <a:noFill/>
+          <a:ln/>
+        </p:spPr>
+        <p:txBody>
+          <a:bodyPr wrap="square" lIns="0" tIns="0" rIns="0" bIns="0" rtlCol="0" anchor="ctr"/>
+          <a:lstStyle/>
+          <a:p>
+            <a:pPr indent="0" marL="0">
+              <a:buNone/>
+            </a:pPr>
+            <a:r>
+              <a:rPr lang="en-US" sz="1500" i="1" dirty="0">
+                <a:solidFill>
+                  <a:srgbClr val="FFF9F0"/>
+                </a:solidFill>
+                <a:latin typeface="Calibri" pitchFamily="34" charset="0"/>
+                <a:ea typeface="Calibri" pitchFamily="34" charset="-122"/>
+                <a:cs typeface="Calibri" pitchFamily="34" charset="-120"/>
+              </a:rPr>
+              <a:t>Start dumb-simple: one /every prompt that reports token usage daily. Then level up with a ready-made GitHub Copilot App template.</a:t>
+            </a:r>
+            <a:endParaRPr lang="en-US" sz="1500" dirty="0"/>
+          </a:p>
+        </p:txBody>
+      </p:sp>
+      <p:sp>
+        <p:nvSpPr>
+          <p:cNvPr id="9" name="Text 6"/>
+          <p:cNvSpPr/>
+          <p:nvPr/>
+        </p:nvSpPr>
+        <p:spPr>
+          <a:xfrm>
+            <a:off x="548640" y="3429000"/>
+            <a:ext cx="8046720" cy="914400"/>
+          </a:xfrm>
+          <a:prstGeom prst="rect">
+            <a:avLst/>
+          </a:prstGeom>
+          <a:noFill/>
+          <a:ln/>
+        </p:spPr>
+        <p:txBody>
+          <a:bodyPr wrap="square" lIns="0" tIns="0" rIns="0" bIns="0" rtlCol="0" anchor="ctr"/>
+          <a:lstStyle/>
+          <a:p>
+            <a:pPr indent="0" marL="0">
+              <a:buNone/>
+            </a:pPr>
+            <a:r>
+              <a:rPr lang="en-US" sz="1400" b="1" dirty="0">
+                <a:solidFill>
+                  <a:srgbClr val="F9E795"/>
+                </a:solidFill>
+                <a:latin typeface="Calibri" pitchFamily="34" charset="0"/>
+                <a:ea typeface="Calibri" pitchFamily="34" charset="-122"/>
+                <a:cs typeface="Calibri" pitchFamily="34" charset="-120"/>
+              </a:rPr>
+              <a:t>Try it: </a:t>
+            </a:r>
+            <a:pPr indent="0" marL="0">
+              <a:buNone/>
+            </a:pPr>
+            <a:r>
+              <a:rPr lang="en-US" sz="1400" dirty="0">
+                <a:solidFill>
+                  <a:srgbClr val="FFFFFF"/>
+                </a:solidFill>
+                <a:latin typeface="Calibri" pitchFamily="34" charset="0"/>
+                <a:ea typeface="Calibri" pitchFamily="34" charset="-122"/>
+                <a:cs typeface="Calibri" pitchFamily="34" charset="-120"/>
+              </a:rPr>
+              <a:t>Schedule the one-line token-usage check, then browse the Copilot App's automation templates for the real morning report.</a:t>
+            </a:r>
+            <a:endParaRPr lang="en-US" sz="1400" dirty="0"/>
+          </a:p>
+        </p:txBody>
+      </p:sp>
+      <p:sp>
+        <p:nvSpPr>
+          <p:cNvPr id="10" name="Text 7"/>
+          <p:cNvSpPr/>
+          <p:nvPr/>
+        </p:nvSpPr>
+        <p:spPr>
+          <a:xfrm>
+            <a:off x="548640" y="4709160"/>
+            <a:ext cx="8046720" cy="274320"/>
+          </a:xfrm>
+          <a:prstGeom prst="rect">
+            <a:avLst/>
+          </a:prstGeom>
+          <a:noFill/>
+          <a:ln/>
+        </p:spPr>
+        <p:txBody>
+          <a:bodyPr wrap="square" lIns="0" tIns="0" rIns="0" bIns="0" rtlCol="0" anchor="ctr"/>
+          <a:lstStyle/>
+          <a:p>
+            <a:pPr algn="l" indent="0" marL="0">
+              <a:buNone/>
+            </a:pPr>
+            <a:r>
+              <a:rPr lang="en-US" sz="1000" dirty="0">
+                <a:solidFill>
+                  <a:srgbClr val="9BA6D6"/>
+                </a:solidFill>
+                <a:latin typeface="Calibri" pitchFamily="34" charset="0"/>
+                <a:ea typeface="Calibri" pitchFamily="34" charset="-122"/>
+                <a:cs typeface="Calibri" pitchFamily="34" charset="-120"/>
+              </a:rPr>
+              <a:t>copilot-cli-lab · day 5 · automate</a:t>
+            </a:r>
+            <a:endParaRPr lang="en-US" sz="1000" dirty="0"/>
+          </a:p>
+        </p:txBody>
+      </p:sp>
+    </p:spTree>
+  </p:cSld>
+  <p:clrMapOvr>
+    <a:masterClrMapping/>
+  </p:clrMapOvr>
+</p:sld>
+</file>
+
+<file path=ppt/slides/slide12.xml><?xml version="1.0" encoding="utf-8"?>
+<p:sld xmlns:a="http://schemas.openxmlformats.org/drawingml/2006/main" xmlns:r="http://schemas.openxmlformats.org/officeDocument/2006/relationships" xmlns:p="http://schemas.openxmlformats.org/presentationml/2006/main">
+  <p:cSld name="Slide 12">
+    <p:bg>
+      <p:bgPr>
+        <a:solidFill>
+          <a:srgbClr val="2F3C7E"/>
+        </a:solidFill>
+      </p:bgPr>
+    </p:bg>
+    <p:spTree>
+      <p:nvGrpSpPr>
+        <p:cNvPr id="1" name=""/>
+        <p:cNvGrpSpPr/>
+        <p:nvPr/>
+      </p:nvGrpSpPr>
+      <p:grpSpPr>
+        <a:xfrm>
+          <a:off x="0" y="0"/>
+          <a:ext cx="0" cy="0"/>
+          <a:chOff x="0" y="0"/>
+          <a:chExt cx="0" cy="0"/>
+        </a:xfrm>
+      </p:grpSpPr>
+      <p:sp>
+        <p:nvSpPr>
+          <p:cNvPr id="2" name="Shape 0"/>
+          <p:cNvSpPr/>
+          <p:nvPr/>
+        </p:nvSpPr>
+        <p:spPr>
+          <a:xfrm>
+            <a:off x="7863840" y="3931920"/>
+            <a:ext cx="2377440" cy="2377440"/>
+          </a:xfrm>
+          <a:prstGeom prst="ellipse">
+            <a:avLst/>
+          </a:prstGeom>
+          <a:solidFill>
+            <a:srgbClr val="F96167">
+              <a:alpha val="16000"/>
+            </a:srgbClr>
+          </a:solidFill>
+          <a:ln/>
+        </p:spPr>
+      </p:sp>
+      <p:sp>
+        <p:nvSpPr>
+          <p:cNvPr id="3" name="Shape 1"/>
+          <p:cNvSpPr/>
+          <p:nvPr/>
+        </p:nvSpPr>
+        <p:spPr>
+          <a:xfrm>
+            <a:off x="548640" y="502920"/>
+            <a:ext cx="868680" cy="868680"/>
+          </a:xfrm>
+          <a:prstGeom prst="ellipse">
+            <a:avLst/>
+          </a:prstGeom>
+          <a:solidFill>
+            <a:srgbClr val="F96167"/>
+          </a:solidFill>
+          <a:ln/>
+        </p:spPr>
+      </p:sp>
+      <p:pic>
+        <p:nvPicPr>
+          <p:cNvPr id="4" name="Image 0" descr="preencoded.png">    </p:cNvPr>
+          <p:cNvPicPr>
+            <a:picLocks noChangeAspect="1"/>
+          </p:cNvPicPr>
+          <p:nvPr/>
+        </p:nvPicPr>
+        <p:blipFill>
+          <a:blip r:embed="rId1"/>
+          <a:stretch>
+            <a:fillRect/>
+          </a:stretch>
+        </p:blipFill>
+        <p:spPr>
+          <a:xfrm>
+            <a:off x="644195" y="598475"/>
+            <a:ext cx="677570" cy="677570"/>
+          </a:xfrm>
+          <a:prstGeom prst="rect">
+            <a:avLst/>
+          </a:prstGeom>
+        </p:spPr>
+      </p:pic>
+      <p:sp>
+        <p:nvSpPr>
+          <p:cNvPr id="5" name="Text 2"/>
+          <p:cNvSpPr/>
+          <p:nvPr/>
+        </p:nvSpPr>
+        <p:spPr>
+          <a:xfrm>
+            <a:off x="1600200" y="566928"/>
+            <a:ext cx="3657600" cy="365760"/>
+          </a:xfrm>
+          <a:prstGeom prst="rect">
+            <a:avLst/>
+          </a:prstGeom>
+          <a:noFill/>
+          <a:ln/>
+        </p:spPr>
+        <p:txBody>
+          <a:bodyPr wrap="square" lIns="0" tIns="0" rIns="0" bIns="0" rtlCol="0" anchor="ctr"/>
+          <a:lstStyle/>
+          <a:p>
+            <a:pPr indent="0" marL="0">
+              <a:buNone/>
+            </a:pPr>
+            <a:r>
+              <a:rPr lang="en-US" sz="1300" b="1" spc="200" kern="0" dirty="0">
+                <a:solidFill>
+                  <a:srgbClr val="F9E795"/>
+                </a:solidFill>
+                <a:latin typeface="Consolas" pitchFamily="34" charset="0"/>
+                <a:ea typeface="Consolas" pitchFamily="34" charset="-122"/>
+                <a:cs typeface="Consolas" pitchFamily="34" charset="-120"/>
+              </a:rPr>
+              <a:t>DAY 6 · SHOW OFF</a:t>
+            </a:r>
+            <a:endParaRPr lang="en-US" sz="1300" dirty="0"/>
+          </a:p>
+        </p:txBody>
+      </p:sp>
+      <p:sp>
+        <p:nvSpPr>
+          <p:cNvPr id="6" name="Text 3"/>
+          <p:cNvSpPr/>
+          <p:nvPr/>
+        </p:nvSpPr>
+        <p:spPr>
+          <a:xfrm>
+            <a:off x="548640" y="1234440"/>
+            <a:ext cx="8046720" cy="822960"/>
+          </a:xfrm>
+          <a:prstGeom prst="rect">
+            <a:avLst/>
+          </a:prstGeom>
+          <a:noFill/>
+          <a:ln/>
+        </p:spPr>
+        <p:txBody>
+          <a:bodyPr wrap="square" lIns="0" tIns="0" rIns="0" bIns="0" rtlCol="0" anchor="ctr"/>
+          <a:lstStyle/>
+          <a:p>
+            <a:pPr indent="0" marL="0">
+              <a:buNone/>
+            </a:pPr>
+            <a:r>
+              <a:rPr lang="en-US" sz="2600" b="1" dirty="0">
+                <a:solidFill>
+                  <a:srgbClr val="FFFFFF"/>
+                </a:solidFill>
+                <a:latin typeface="Georgia" pitchFamily="34" charset="0"/>
+                <a:ea typeface="Georgia" pitchFamily="34" charset="-122"/>
+                <a:cs typeface="Georgia" pitchFamily="34" charset="-120"/>
+              </a:rPr>
+              <a:t>Build the Deck With /pptx</a:t>
+            </a:r>
+            <a:endParaRPr lang="en-US" sz="2600" dirty="0"/>
+          </a:p>
+        </p:txBody>
+      </p:sp>
+      <p:sp>
+        <p:nvSpPr>
+          <p:cNvPr id="7" name="Shape 4"/>
+          <p:cNvSpPr/>
+          <p:nvPr/>
+        </p:nvSpPr>
+        <p:spPr>
+          <a:xfrm>
+            <a:off x="548640" y="2148840"/>
+            <a:ext cx="8046720" cy="1051560"/>
+          </a:xfrm>
+          <a:prstGeom prst="rect">
+            <a:avLst/>
+          </a:prstGeom>
+          <a:solidFill>
+            <a:srgbClr val="FFFFFF">
+              <a:alpha val="8000"/>
+            </a:srgbClr>
+          </a:solidFill>
+          <a:ln/>
+        </p:spPr>
+      </p:sp>
+      <p:sp>
+        <p:nvSpPr>
+          <p:cNvPr id="8" name="Text 5"/>
+          <p:cNvSpPr/>
+          <p:nvPr/>
+        </p:nvSpPr>
+        <p:spPr>
+          <a:xfrm>
+            <a:off x="822960" y="2240280"/>
+            <a:ext cx="7498080" cy="868680"/>
+          </a:xfrm>
+          <a:prstGeom prst="rect">
+            <a:avLst/>
+          </a:prstGeom>
+          <a:noFill/>
+          <a:ln/>
+        </p:spPr>
+        <p:txBody>
+          <a:bodyPr wrap="square" lIns="0" tIns="0" rIns="0" bIns="0" rtlCol="0" anchor="ctr"/>
+          <a:lstStyle/>
+          <a:p>
+            <a:pPr indent="0" marL="0">
+              <a:buNone/>
+            </a:pPr>
+            <a:r>
+              <a:rPr lang="en-US" sz="1500" i="1" dirty="0">
+                <a:solidFill>
+                  <a:srgbClr val="FFF9F0"/>
+                </a:solidFill>
+                <a:latin typeface="Calibri" pitchFamily="34" charset="0"/>
+                <a:ea typeface="Calibri" pitchFamily="34" charset="-122"/>
+                <a:cs typeface="Calibri" pitchFamily="34" charset="-120"/>
+              </a:rPr>
+              <a:t>The same pptx skill that built this deck can build yours - straight from this repo's READMEs and commit history.</a:t>
+            </a:r>
+            <a:endParaRPr lang="en-US" sz="1500" dirty="0"/>
+          </a:p>
+        </p:txBody>
+      </p:sp>
+      <p:sp>
+        <p:nvSpPr>
+          <p:cNvPr id="9" name="Text 6"/>
+          <p:cNvSpPr/>
+          <p:nvPr/>
+        </p:nvSpPr>
+        <p:spPr>
+          <a:xfrm>
+            <a:off x="548640" y="3429000"/>
+            <a:ext cx="8046720" cy="914400"/>
+          </a:xfrm>
+          <a:prstGeom prst="rect">
+            <a:avLst/>
+          </a:prstGeom>
+          <a:noFill/>
+          <a:ln/>
+        </p:spPr>
+        <p:txBody>
+          <a:bodyPr wrap="square" lIns="0" tIns="0" rIns="0" bIns="0" rtlCol="0" anchor="ctr"/>
+          <a:lstStyle/>
+          <a:p>
+            <a:pPr indent="0" marL="0">
+              <a:buNone/>
+            </a:pPr>
+            <a:r>
+              <a:rPr lang="en-US" sz="1400" b="1" dirty="0">
+                <a:solidFill>
+                  <a:srgbClr val="F9E795"/>
+                </a:solidFill>
+                <a:latin typeface="Calibri" pitchFamily="34" charset="0"/>
+                <a:ea typeface="Calibri" pitchFamily="34" charset="-122"/>
+                <a:cs typeface="Calibri" pitchFamily="34" charset="-120"/>
+              </a:rPr>
+              <a:t>Try it: </a:t>
+            </a:r>
+            <a:pPr indent="0" marL="0">
+              <a:buNone/>
+            </a:pPr>
+            <a:r>
+              <a:rPr lang="en-US" sz="1400" dirty="0">
+                <a:solidFill>
+                  <a:srgbClr val="FFFFFF"/>
+                </a:solidFill>
+                <a:latin typeface="Calibri" pitchFamily="34" charset="0"/>
+                <a:ea typeface="Calibri" pitchFamily="34" charset="-122"/>
+                <a:cs typeface="Calibri" pitchFamily="34" charset="-120"/>
+              </a:rPr>
+              <a:t>Ask Copilot to build a 6-8 slide demo-day deck from this repo, then present it in under 2 minutes.</a:t>
+            </a:r>
+            <a:endParaRPr lang="en-US" sz="1400" dirty="0"/>
+          </a:p>
+        </p:txBody>
+      </p:sp>
+      <p:sp>
+        <p:nvSpPr>
+          <p:cNvPr id="10" name="Text 7"/>
+          <p:cNvSpPr/>
+          <p:nvPr/>
+        </p:nvSpPr>
+        <p:spPr>
+          <a:xfrm>
+            <a:off x="548640" y="4709160"/>
+            <a:ext cx="8046720" cy="274320"/>
+          </a:xfrm>
+          <a:prstGeom prst="rect">
+            <a:avLst/>
+          </a:prstGeom>
+          <a:noFill/>
+          <a:ln/>
+        </p:spPr>
+        <p:txBody>
+          <a:bodyPr wrap="square" lIns="0" tIns="0" rIns="0" bIns="0" rtlCol="0" anchor="ctr"/>
+          <a:lstStyle/>
+          <a:p>
+            <a:pPr algn="l" indent="0" marL="0">
+              <a:buNone/>
+            </a:pPr>
+            <a:r>
+              <a:rPr lang="en-US" sz="1000" dirty="0">
+                <a:solidFill>
+                  <a:srgbClr val="9BA6D6"/>
+                </a:solidFill>
+                <a:latin typeface="Calibri" pitchFamily="34" charset="0"/>
+                <a:ea typeface="Calibri" pitchFamily="34" charset="-122"/>
+                <a:cs typeface="Calibri" pitchFamily="34" charset="-120"/>
+              </a:rPr>
+              <a:t>copilot-cli-lab · day 6 · show off</a:t>
+            </a:r>
+            <a:endParaRPr lang="en-US" sz="1000" dirty="0"/>
+          </a:p>
+        </p:txBody>
+      </p:sp>
+    </p:spTree>
+  </p:cSld>
+  <p:clrMapOvr>
+    <a:masterClrMapping/>
+  </p:clrMapOvr>
+</p:sld>
+</file>
+
+<file path=ppt/slides/slide13.xml><?xml version="1.0" encoding="utf-8"?>
+<p:sld xmlns:a="http://schemas.openxmlformats.org/drawingml/2006/main" xmlns:r="http://schemas.openxmlformats.org/officeDocument/2006/relationships" xmlns:p="http://schemas.openxmlformats.org/presentationml/2006/main">
+  <p:cSld name="Slide 13">
+    <p:bg>
+      <p:bgPr>
+        <a:solidFill>
+          <a:srgbClr val="2F3C7E"/>
+        </a:solidFill>
+      </p:bgPr>
+    </p:bg>
+    <p:spTree>
+      <p:nvGrpSpPr>
+        <p:cNvPr id="1" name=""/>
+        <p:cNvGrpSpPr/>
+        <p:nvPr/>
+      </p:nvGrpSpPr>
+      <p:grpSpPr>
+        <a:xfrm>
+          <a:off x="0" y="0"/>
+          <a:ext cx="0" cy="0"/>
+          <a:chOff x="0" y="0"/>
+          <a:chExt cx="0" cy="0"/>
+        </a:xfrm>
+      </p:grpSpPr>
+      <p:sp>
+        <p:nvSpPr>
+          <p:cNvPr id="2" name="Shape 0"/>
+          <p:cNvSpPr/>
+          <p:nvPr/>
+        </p:nvSpPr>
+        <p:spPr>
+          <a:xfrm>
+            <a:off x="7863840" y="3931920"/>
+            <a:ext cx="2377440" cy="2377440"/>
+          </a:xfrm>
+          <a:prstGeom prst="ellipse">
+            <a:avLst/>
+          </a:prstGeom>
+          <a:solidFill>
+            <a:srgbClr val="F96167">
+              <a:alpha val="16000"/>
+            </a:srgbClr>
+          </a:solidFill>
+          <a:ln/>
+        </p:spPr>
+      </p:sp>
+      <p:sp>
+        <p:nvSpPr>
+          <p:cNvPr id="3" name="Shape 1"/>
+          <p:cNvSpPr/>
+          <p:nvPr/>
+        </p:nvSpPr>
+        <p:spPr>
+          <a:xfrm>
+            <a:off x="548640" y="502920"/>
+            <a:ext cx="868680" cy="868680"/>
+          </a:xfrm>
+          <a:prstGeom prst="ellipse">
+            <a:avLst/>
+          </a:prstGeom>
+          <a:solidFill>
+            <a:srgbClr val="F96167"/>
+          </a:solidFill>
+          <a:ln/>
+        </p:spPr>
+      </p:sp>
+      <p:pic>
+        <p:nvPicPr>
+          <p:cNvPr id="4" name="Image 0" descr="preencoded.png">    </p:cNvPr>
+          <p:cNvPicPr>
+            <a:picLocks noChangeAspect="1"/>
+          </p:cNvPicPr>
+          <p:nvPr/>
+        </p:nvPicPr>
+        <p:blipFill>
+          <a:blip r:embed="rId1"/>
+          <a:stretch>
+            <a:fillRect/>
+          </a:stretch>
+        </p:blipFill>
+        <p:spPr>
+          <a:xfrm>
+            <a:off x="644195" y="598475"/>
+            <a:ext cx="677570" cy="677570"/>
+          </a:xfrm>
+          <a:prstGeom prst="rect">
+            <a:avLst/>
+          </a:prstGeom>
+        </p:spPr>
+      </p:pic>
+      <p:sp>
+        <p:nvSpPr>
+          <p:cNvPr id="5" name="Text 2"/>
+          <p:cNvSpPr/>
+          <p:nvPr/>
+        </p:nvSpPr>
+        <p:spPr>
+          <a:xfrm>
+            <a:off x="1600200" y="566928"/>
+            <a:ext cx="3657600" cy="365760"/>
+          </a:xfrm>
+          <a:prstGeom prst="rect">
+            <a:avLst/>
+          </a:prstGeom>
+          <a:noFill/>
+          <a:ln/>
+        </p:spPr>
+        <p:txBody>
+          <a:bodyPr wrap="square" lIns="0" tIns="0" rIns="0" bIns="0" rtlCol="0" anchor="ctr"/>
+          <a:lstStyle/>
+          <a:p>
+            <a:pPr indent="0" marL="0">
+              <a:buNone/>
+            </a:pPr>
+            <a:r>
+              <a:rPr lang="en-US" sz="1300" b="1" spc="200" kern="0" dirty="0">
+                <a:solidFill>
+                  <a:srgbClr val="F9E795"/>
+                </a:solidFill>
+                <a:latin typeface="Consolas" pitchFamily="34" charset="0"/>
+                <a:ea typeface="Consolas" pitchFamily="34" charset="-122"/>
+                <a:cs typeface="Consolas" pitchFamily="34" charset="-120"/>
+              </a:rPr>
+              <a:t>BONUS · BUDGET</a:t>
+            </a:r>
+            <a:endParaRPr lang="en-US" sz="1300" dirty="0"/>
+          </a:p>
+        </p:txBody>
+      </p:sp>
+      <p:sp>
+        <p:nvSpPr>
+          <p:cNvPr id="6" name="Text 3"/>
+          <p:cNvSpPr/>
+          <p:nvPr/>
+        </p:nvSpPr>
+        <p:spPr>
+          <a:xfrm>
+            <a:off x="548640" y="1234440"/>
+            <a:ext cx="8046720" cy="822960"/>
+          </a:xfrm>
+          <a:prstGeom prst="rect">
+            <a:avLst/>
+          </a:prstGeom>
+          <a:noFill/>
+          <a:ln/>
+        </p:spPr>
+        <p:txBody>
+          <a:bodyPr wrap="square" lIns="0" tIns="0" rIns="0" bIns="0" rtlCol="0" anchor="ctr"/>
+          <a:lstStyle/>
+          <a:p>
+            <a:pPr indent="0" marL="0">
+              <a:buNone/>
+            </a:pPr>
+            <a:r>
+              <a:rPr lang="en-US" sz="2600" b="1" dirty="0">
+                <a:solidFill>
+                  <a:srgbClr val="FFFFFF"/>
+                </a:solidFill>
+                <a:latin typeface="Georgia" pitchFamily="34" charset="0"/>
+                <a:ea typeface="Georgia" pitchFamily="34" charset="-122"/>
+                <a:cs typeface="Georgia" pitchFamily="34" charset="-120"/>
+              </a:rPr>
+              <a:t>Keeping the Sprint Sustainable</a:t>
+            </a:r>
+            <a:endParaRPr lang="en-US" sz="2600" dirty="0"/>
+          </a:p>
+        </p:txBody>
+      </p:sp>
+      <p:sp>
+        <p:nvSpPr>
+          <p:cNvPr id="7" name="Shape 4"/>
+          <p:cNvSpPr/>
+          <p:nvPr/>
+        </p:nvSpPr>
+        <p:spPr>
+          <a:xfrm>
+            <a:off x="548640" y="2148840"/>
+            <a:ext cx="8046720" cy="1051560"/>
+          </a:xfrm>
+          <a:prstGeom prst="rect">
+            <a:avLst/>
+          </a:prstGeom>
+          <a:solidFill>
+            <a:srgbClr val="FFFFFF">
+              <a:alpha val="8000"/>
+            </a:srgbClr>
+          </a:solidFill>
+          <a:ln/>
+        </p:spPr>
+      </p:sp>
+      <p:sp>
+        <p:nvSpPr>
+          <p:cNvPr id="8" name="Text 5"/>
+          <p:cNvSpPr/>
+          <p:nvPr/>
+        </p:nvSpPr>
+        <p:spPr>
+          <a:xfrm>
+            <a:off x="822960" y="2240280"/>
+            <a:ext cx="7498080" cy="868680"/>
+          </a:xfrm>
+          <a:prstGeom prst="rect">
+            <a:avLst/>
+          </a:prstGeom>
+          <a:noFill/>
+          <a:ln/>
+        </p:spPr>
+        <p:txBody>
+          <a:bodyPr wrap="square" lIns="0" tIns="0" rIns="0" bIns="0" rtlCol="0" anchor="ctr"/>
+          <a:lstStyle/>
+          <a:p>
+            <a:pPr indent="0" marL="0">
+              <a:buNone/>
+            </a:pPr>
+            <a:r>
+              <a:rPr lang="en-US" sz="1500" i="1" dirty="0">
+                <a:solidFill>
+                  <a:srgbClr val="FFF9F0"/>
+                </a:solidFill>
+                <a:latin typeface="Calibri" pitchFamily="34" charset="0"/>
+                <a:ea typeface="Calibri" pitchFamily="34" charset="-122"/>
+                <a:cs typeface="Calibri" pitchFamily="34" charset="-120"/>
+              </a:rPr>
+              <a:t>Before rolling this out org-wide, the team checks seats, usage, and budget alerts in GitHub billing.</a:t>
+            </a:r>
+            <a:endParaRPr lang="en-US" sz="1500" dirty="0"/>
+          </a:p>
+        </p:txBody>
+      </p:sp>
+      <p:sp>
+        <p:nvSpPr>
+          <p:cNvPr id="9" name="Text 6"/>
+          <p:cNvSpPr/>
+          <p:nvPr/>
+        </p:nvSpPr>
+        <p:spPr>
+          <a:xfrm>
+            <a:off x="548640" y="3429000"/>
+            <a:ext cx="8046720" cy="914400"/>
+          </a:xfrm>
+          <a:prstGeom prst="rect">
+            <a:avLst/>
+          </a:prstGeom>
+          <a:noFill/>
+          <a:ln/>
+        </p:spPr>
+        <p:txBody>
+          <a:bodyPr wrap="square" lIns="0" tIns="0" rIns="0" bIns="0" rtlCol="0" anchor="ctr"/>
+          <a:lstStyle/>
+          <a:p>
+            <a:pPr indent="0" marL="0">
+              <a:buNone/>
+            </a:pPr>
+            <a:r>
+              <a:rPr lang="en-US" sz="1400" b="1" dirty="0">
+                <a:solidFill>
+                  <a:srgbClr val="F9E795"/>
+                </a:solidFill>
+                <a:latin typeface="Calibri" pitchFamily="34" charset="0"/>
+                <a:ea typeface="Calibri" pitchFamily="34" charset="-122"/>
+                <a:cs typeface="Calibri" pitchFamily="34" charset="-120"/>
+              </a:rPr>
+              <a:t>Try it: </a:t>
+            </a:r>
+            <a:pPr indent="0" marL="0">
+              <a:buNone/>
+            </a:pPr>
+            <a:r>
+              <a:rPr lang="en-US" sz="1400" dirty="0">
+                <a:solidFill>
+                  <a:srgbClr val="FFFFFF"/>
+                </a:solidFill>
+                <a:latin typeface="Calibri" pitchFamily="34" charset="0"/>
+                <a:ea typeface="Calibri" pitchFamily="34" charset="-122"/>
+                <a:cs typeface="Calibri" pitchFamily="34" charset="-120"/>
+              </a:rPr>
+              <a:t>Find your Copilot usage in Settings → Billing, and guess your monthly spend before you look.</a:t>
+            </a:r>
+            <a:endParaRPr lang="en-US" sz="1400" dirty="0"/>
+          </a:p>
+        </p:txBody>
+      </p:sp>
+      <p:sp>
+        <p:nvSpPr>
+          <p:cNvPr id="10" name="Text 7"/>
+          <p:cNvSpPr/>
+          <p:nvPr/>
+        </p:nvSpPr>
+        <p:spPr>
+          <a:xfrm>
+            <a:off x="548640" y="4709160"/>
+            <a:ext cx="8046720" cy="274320"/>
+          </a:xfrm>
+          <a:prstGeom prst="rect">
+            <a:avLst/>
+          </a:prstGeom>
+          <a:noFill/>
+          <a:ln/>
+        </p:spPr>
+        <p:txBody>
+          <a:bodyPr wrap="square" lIns="0" tIns="0" rIns="0" bIns="0" rtlCol="0" anchor="ctr"/>
+          <a:lstStyle/>
+          <a:p>
+            <a:pPr algn="l" indent="0" marL="0">
+              <a:buNone/>
+            </a:pPr>
+            <a:r>
+              <a:rPr lang="en-US" sz="1000" dirty="0">
+                <a:solidFill>
+                  <a:srgbClr val="9BA6D6"/>
+                </a:solidFill>
+                <a:latin typeface="Calibri" pitchFamily="34" charset="0"/>
+                <a:ea typeface="Calibri" pitchFamily="34" charset="-122"/>
+                <a:cs typeface="Calibri" pitchFamily="34" charset="-120"/>
+              </a:rPr>
+              <a:t>copilot-cli-lab · bonus · budget</a:t>
+            </a:r>
+            <a:endParaRPr lang="en-US" sz="1000" dirty="0"/>
+          </a:p>
+        </p:txBody>
+      </p:sp>
+    </p:spTree>
+  </p:cSld>
+  <p:clrMapOvr>
+    <a:masterClrMapping/>
+  </p:clrMapOvr>
+</p:sld>
+</file>
+
+<file path=ppt/slides/slide14.xml><?xml version="1.0" encoding="utf-8"?>
+<p:sld xmlns:a="http://schemas.openxmlformats.org/drawingml/2006/main" xmlns:r="http://schemas.openxmlformats.org/officeDocument/2006/relationships" xmlns:p="http://schemas.openxmlformats.org/presentationml/2006/main">
+  <p:cSld name="Slide 14">
+    <p:bg>
+      <p:bgPr>
+        <a:solidFill>
+          <a:srgbClr val="FFF9F0"/>
+        </a:solidFill>
+      </p:bgPr>
+    </p:bg>
+    <p:spTree>
+      <p:nvGrpSpPr>
+        <p:cNvPr id="1" name=""/>
+        <p:cNvGrpSpPr/>
+        <p:nvPr/>
+      </p:nvGrpSpPr>
+      <p:grpSpPr>
+        <a:xfrm>
+          <a:off x="0" y="0"/>
+          <a:ext cx="0" cy="0"/>
+          <a:chOff x="0" y="0"/>
+          <a:chExt cx="0" cy="0"/>
+        </a:xfrm>
+      </p:grpSpPr>
+      <p:sp>
+        <p:nvSpPr>
+          <p:cNvPr id="2" name="Text 0"/>
+          <p:cNvSpPr/>
+          <p:nvPr/>
+        </p:nvSpPr>
+        <p:spPr>
+          <a:xfrm>
+            <a:off x="457200" y="411480"/>
+            <a:ext cx="8229600" cy="548640"/>
+          </a:xfrm>
+          <a:prstGeom prst="rect">
+            <a:avLst/>
+          </a:prstGeom>
+          <a:noFill/>
+          <a:ln/>
+        </p:spPr>
+        <p:txBody>
+          <a:bodyPr wrap="square" lIns="0" tIns="0" rIns="0" bIns="0" rtlCol="0" anchor="ctr"/>
+          <a:lstStyle/>
+          <a:p>
+            <a:pPr indent="0" marL="0">
+              <a:buNone/>
+            </a:pPr>
+            <a:r>
+              <a:rPr lang="en-US" sz="2800" b="1" dirty="0">
+                <a:solidFill>
+                  <a:srgbClr val="2B2118"/>
+                </a:solidFill>
+                <a:latin typeface="Georgia" pitchFamily="34" charset="0"/>
+                <a:ea typeface="Georgia" pitchFamily="34" charset="-122"/>
+                <a:cs typeface="Georgia" pitchFamily="34" charset="-120"/>
+              </a:rPr>
+              <a:t>Pricing &amp; Budgeting, In Brief</a:t>
+            </a:r>
+            <a:endParaRPr lang="en-US" sz="2800" dirty="0"/>
+          </a:p>
+        </p:txBody>
+      </p:sp>
+      <p:sp>
+        <p:nvSpPr>
+          <p:cNvPr id="3" name="Shape 1"/>
+          <p:cNvSpPr/>
+          <p:nvPr/>
+        </p:nvSpPr>
+        <p:spPr>
+          <a:xfrm>
+            <a:off x="457200" y="1371600"/>
+            <a:ext cx="2606040" cy="2651760"/>
+          </a:xfrm>
+          <a:prstGeom prst="rect">
+            <a:avLst/>
+          </a:prstGeom>
+          <a:solidFill>
+            <a:srgbClr val="FFFFFF"/>
+          </a:solidFill>
+          <a:ln w="12700">
+            <a:solidFill>
+              <a:srgbClr val="EFE3D3"/>
+            </a:solidFill>
+            <a:prstDash val="solid"/>
+          </a:ln>
+          <a:effectLst>
+            <a:outerShdw sx="100000" sy="100000" kx="0" ky="0" algn="bl" rotWithShape="0" blurRad="76200" dist="25400" dir="8100000">
+              <a:srgbClr val="000000">
+                <a:alpha val="10000"/>
+              </a:srgbClr>
+            </a:outerShdw>
+          </a:effectLst>
+        </p:spPr>
+      </p:sp>
+      <p:sp>
+        <p:nvSpPr>
+          <p:cNvPr id="4" name="Shape 2"/>
+          <p:cNvSpPr/>
+          <p:nvPr/>
+        </p:nvSpPr>
+        <p:spPr>
+          <a:xfrm>
+            <a:off x="457200" y="1371600"/>
+            <a:ext cx="2606040" cy="109728"/>
+          </a:xfrm>
+          <a:prstGeom prst="rect">
+            <a:avLst/>
+          </a:prstGeom>
+          <a:solidFill>
+            <a:srgbClr val="2F3C7E"/>
+          </a:solidFill>
+          <a:ln/>
+        </p:spPr>
+      </p:sp>
+      <p:sp>
+        <p:nvSpPr>
+          <p:cNvPr id="5" name="Shape 3"/>
+          <p:cNvSpPr/>
+          <p:nvPr/>
+        </p:nvSpPr>
+        <p:spPr>
+          <a:xfrm>
+            <a:off x="640080" y="1691640"/>
+            <a:ext cx="548640" cy="548640"/>
+          </a:xfrm>
+          <a:prstGeom prst="ellipse">
+            <a:avLst/>
+          </a:prstGeom>
+          <a:solidFill>
+            <a:srgbClr val="F96167"/>
+          </a:solidFill>
+          <a:ln/>
+        </p:spPr>
+      </p:sp>
+      <p:pic>
+        <p:nvPicPr>
+          <p:cNvPr id="6" name="Image 0" descr="preencoded.png">    </p:cNvPr>
+          <p:cNvPicPr>
+            <a:picLocks noChangeAspect="1"/>
+          </p:cNvPicPr>
+          <p:nvPr/>
+        </p:nvPicPr>
+        <p:blipFill>
+          <a:blip r:embed="rId1"/>
+          <a:stretch>
+            <a:fillRect/>
+          </a:stretch>
+        </p:blipFill>
+        <p:spPr>
+          <a:xfrm>
+            <a:off x="700430" y="1751990"/>
+            <a:ext cx="427939" cy="427939"/>
+          </a:xfrm>
+          <a:prstGeom prst="rect">
+            <a:avLst/>
+          </a:prstGeom>
+        </p:spPr>
+      </p:pic>
+      <p:sp>
+        <p:nvSpPr>
+          <p:cNvPr id="7" name="Text 4"/>
+          <p:cNvSpPr/>
+          <p:nvPr/>
+        </p:nvSpPr>
+        <p:spPr>
+          <a:xfrm>
+            <a:off x="1371600" y="1691640"/>
+            <a:ext cx="1554480" cy="548640"/>
+          </a:xfrm>
+          <a:prstGeom prst="rect">
+            <a:avLst/>
+          </a:prstGeom>
+          <a:noFill/>
+          <a:ln/>
+        </p:spPr>
+        <p:txBody>
+          <a:bodyPr wrap="square" lIns="0" tIns="0" rIns="0" bIns="0" rtlCol="0" anchor="ctr"/>
+          <a:lstStyle/>
+          <a:p>
+            <a:pPr indent="0" marL="0">
+              <a:buNone/>
+            </a:pPr>
+            <a:r>
+              <a:rPr lang="en-US" sz="1500" b="1" dirty="0">
+                <a:solidFill>
+                  <a:srgbClr val="2F3C7E"/>
+                </a:solidFill>
+                <a:latin typeface="Georgia" pitchFamily="34" charset="0"/>
+                <a:ea typeface="Georgia" pitchFamily="34" charset="-122"/>
+                <a:cs typeface="Georgia" pitchFamily="34" charset="-120"/>
+              </a:rPr>
+              <a:t>Two billing layers</a:t>
+            </a:r>
+            <a:endParaRPr lang="en-US" sz="1500" dirty="0"/>
+          </a:p>
+        </p:txBody>
+      </p:sp>
+      <p:sp>
+        <p:nvSpPr>
+          <p:cNvPr id="8" name="Text 5"/>
+          <p:cNvSpPr/>
+          <p:nvPr/>
+        </p:nvSpPr>
+        <p:spPr>
+          <a:xfrm>
+            <a:off x="640080" y="2423160"/>
+            <a:ext cx="2240280" cy="1463040"/>
+          </a:xfrm>
+          <a:prstGeom prst="rect">
+            <a:avLst/>
+          </a:prstGeom>
+          <a:noFill/>
+          <a:ln/>
+        </p:spPr>
+        <p:txBody>
+          <a:bodyPr wrap="square" lIns="0" tIns="0" rIns="0" bIns="0" rtlCol="0" anchor="ctr"/>
+          <a:lstStyle/>
+          <a:p>
+            <a:pPr indent="0" marL="0">
+              <a:buNone/>
+            </a:pPr>
+            <a:r>
+              <a:rPr lang="en-US" sz="1250" dirty="0">
+                <a:solidFill>
+                  <a:srgbClr val="4A4038"/>
+                </a:solidFill>
+                <a:latin typeface="Calibri" pitchFamily="34" charset="0"/>
+                <a:ea typeface="Calibri" pitchFamily="34" charset="-122"/>
+                <a:cs typeface="Calibri" pitchFamily="34" charset="-120"/>
+              </a:rPr>
+              <a:t>Flat per-seat cost, plus usage-based premium requests/tokens driven by model choice &amp; context size.</a:t>
+            </a:r>
+            <a:endParaRPr lang="en-US" sz="1250" dirty="0"/>
+          </a:p>
+        </p:txBody>
+      </p:sp>
+      <p:sp>
+        <p:nvSpPr>
+          <p:cNvPr id="9" name="Shape 6"/>
+          <p:cNvSpPr/>
+          <p:nvPr/>
+        </p:nvSpPr>
+        <p:spPr>
+          <a:xfrm>
+            <a:off x="3291840" y="1371600"/>
+            <a:ext cx="2606040" cy="2651760"/>
+          </a:xfrm>
+          <a:prstGeom prst="rect">
+            <a:avLst/>
+          </a:prstGeom>
+          <a:solidFill>
+            <a:srgbClr val="FFFFFF"/>
+          </a:solidFill>
+          <a:ln w="12700">
+            <a:solidFill>
+              <a:srgbClr val="EFE3D3"/>
+            </a:solidFill>
+            <a:prstDash val="solid"/>
+          </a:ln>
+          <a:effectLst>
+            <a:outerShdw sx="100000" sy="100000" kx="0" ky="0" algn="bl" rotWithShape="0" blurRad="76200" dist="25400" dir="8100000">
+              <a:srgbClr val="000000">
+                <a:alpha val="10000"/>
+              </a:srgbClr>
+            </a:outerShdw>
+          </a:effectLst>
+        </p:spPr>
+      </p:sp>
+      <p:sp>
+        <p:nvSpPr>
+          <p:cNvPr id="10" name="Shape 7"/>
+          <p:cNvSpPr/>
+          <p:nvPr/>
+        </p:nvSpPr>
+        <p:spPr>
+          <a:xfrm>
+            <a:off x="3291840" y="1371600"/>
+            <a:ext cx="2606040" cy="109728"/>
+          </a:xfrm>
+          <a:prstGeom prst="rect">
+            <a:avLst/>
+          </a:prstGeom>
+          <a:solidFill>
+            <a:srgbClr val="2F3C7E"/>
+          </a:solidFill>
+          <a:ln/>
+        </p:spPr>
+      </p:sp>
+      <p:sp>
+        <p:nvSpPr>
+          <p:cNvPr id="11" name="Shape 8"/>
+          <p:cNvSpPr/>
+          <p:nvPr/>
+        </p:nvSpPr>
+        <p:spPr>
+          <a:xfrm>
+            <a:off x="3474720" y="1691640"/>
+            <a:ext cx="548640" cy="548640"/>
+          </a:xfrm>
+          <a:prstGeom prst="ellipse">
+            <a:avLst/>
+          </a:prstGeom>
+          <a:solidFill>
+            <a:srgbClr val="F96167"/>
+          </a:solidFill>
+          <a:ln/>
+        </p:spPr>
+      </p:sp>
+      <p:pic>
+        <p:nvPicPr>
+          <p:cNvPr id="12" name="Image 1" descr="preencoded.png">    </p:cNvPr>
+          <p:cNvPicPr>
+            <a:picLocks noChangeAspect="1"/>
+          </p:cNvPicPr>
+          <p:nvPr/>
+        </p:nvPicPr>
+        <p:blipFill>
+          <a:blip r:embed="rId2"/>
+          <a:stretch>
+            <a:fillRect/>
+          </a:stretch>
+        </p:blipFill>
+        <p:spPr>
+          <a:xfrm>
+            <a:off x="3535070" y="1751990"/>
+            <a:ext cx="427939" cy="427939"/>
+          </a:xfrm>
+          <a:prstGeom prst="rect">
+            <a:avLst/>
+          </a:prstGeom>
+        </p:spPr>
+      </p:pic>
+      <p:sp>
+        <p:nvSpPr>
+          <p:cNvPr id="13" name="Text 9"/>
+          <p:cNvSpPr/>
+          <p:nvPr/>
+        </p:nvSpPr>
+        <p:spPr>
+          <a:xfrm>
+            <a:off x="4206240" y="1691640"/>
+            <a:ext cx="1554480" cy="548640"/>
+          </a:xfrm>
+          <a:prstGeom prst="rect">
+            <a:avLst/>
+          </a:prstGeom>
+          <a:noFill/>
+          <a:ln/>
+        </p:spPr>
+        <p:txBody>
+          <a:bodyPr wrap="square" lIns="0" tIns="0" rIns="0" bIns="0" rtlCol="0" anchor="ctr"/>
+          <a:lstStyle/>
+          <a:p>
+            <a:pPr indent="0" marL="0">
+              <a:buNone/>
+            </a:pPr>
+            <a:r>
+              <a:rPr lang="en-US" sz="1500" b="1" dirty="0">
+                <a:solidFill>
+                  <a:srgbClr val="2F3C7E"/>
+                </a:solidFill>
+                <a:latin typeface="Georgia" pitchFamily="34" charset="0"/>
+                <a:ea typeface="Georgia" pitchFamily="34" charset="-122"/>
+                <a:cs typeface="Georgia" pitchFamily="34" charset="-120"/>
+              </a:rPr>
+              <a:t>Layered budgets</a:t>
+            </a:r>
+            <a:endParaRPr lang="en-US" sz="1500" dirty="0"/>
+          </a:p>
+        </p:txBody>
+      </p:sp>
+      <p:sp>
+        <p:nvSpPr>
+          <p:cNvPr id="14" name="Text 10"/>
+          <p:cNvSpPr/>
+          <p:nvPr/>
+        </p:nvSpPr>
+        <p:spPr>
+          <a:xfrm>
+            <a:off x="3474720" y="2423160"/>
+            <a:ext cx="2240280" cy="1463040"/>
+          </a:xfrm>
+          <a:prstGeom prst="rect">
+            <a:avLst/>
+          </a:prstGeom>
+          <a:noFill/>
+          <a:ln/>
+        </p:spPr>
+        <p:txBody>
+          <a:bodyPr wrap="square" lIns="0" tIns="0" rIns="0" bIns="0" rtlCol="0" anchor="ctr"/>
+          <a:lstStyle/>
+          <a:p>
+            <a:pPr indent="0" marL="0">
+              <a:buNone/>
+            </a:pPr>
+            <a:r>
+              <a:rPr lang="en-US" sz="1250" dirty="0">
+                <a:solidFill>
+                  <a:srgbClr val="4A4038"/>
+                </a:solidFill>
+                <a:latin typeface="Calibri" pitchFamily="34" charset="0"/>
+                <a:ea typeface="Calibri" pitchFamily="34" charset="-122"/>
+                <a:cs typeface="Calibri" pitchFamily="34" charset="-120"/>
+              </a:rPr>
+              <a:t>Org-wide caps, with team/project budgets underneath, so one workflow can't blow the whole spend.</a:t>
+            </a:r>
+            <a:endParaRPr lang="en-US" sz="1250" dirty="0"/>
+          </a:p>
+        </p:txBody>
+      </p:sp>
+      <p:sp>
+        <p:nvSpPr>
+          <p:cNvPr id="15" name="Shape 11"/>
+          <p:cNvSpPr/>
+          <p:nvPr/>
+        </p:nvSpPr>
+        <p:spPr>
+          <a:xfrm>
+            <a:off x="6126480" y="1371600"/>
+            <a:ext cx="2606040" cy="2651760"/>
+          </a:xfrm>
+          <a:prstGeom prst="rect">
+            <a:avLst/>
+          </a:prstGeom>
+          <a:solidFill>
+            <a:srgbClr val="FFFFFF"/>
+          </a:solidFill>
+          <a:ln w="12700">
+            <a:solidFill>
+              <a:srgbClr val="EFE3D3"/>
+            </a:solidFill>
+            <a:prstDash val="solid"/>
+          </a:ln>
+          <a:effectLst>
+            <a:outerShdw sx="100000" sy="100000" kx="0" ky="0" algn="bl" rotWithShape="0" blurRad="76200" dist="25400" dir="8100000">
+              <a:srgbClr val="000000">
+                <a:alpha val="10000"/>
+              </a:srgbClr>
+            </a:outerShdw>
+          </a:effectLst>
+        </p:spPr>
+      </p:sp>
+      <p:sp>
+        <p:nvSpPr>
+          <p:cNvPr id="16" name="Shape 12"/>
+          <p:cNvSpPr/>
+          <p:nvPr/>
+        </p:nvSpPr>
+        <p:spPr>
+          <a:xfrm>
+            <a:off x="6126480" y="1371600"/>
+            <a:ext cx="2606040" cy="109728"/>
+          </a:xfrm>
+          <a:prstGeom prst="rect">
+            <a:avLst/>
+          </a:prstGeom>
+          <a:solidFill>
+            <a:srgbClr val="2F3C7E"/>
+          </a:solidFill>
+          <a:ln/>
+        </p:spPr>
+      </p:sp>
+      <p:sp>
+        <p:nvSpPr>
+          <p:cNvPr id="17" name="Shape 13"/>
+          <p:cNvSpPr/>
+          <p:nvPr/>
+        </p:nvSpPr>
+        <p:spPr>
+          <a:xfrm>
+            <a:off x="6309360" y="1691640"/>
+            <a:ext cx="548640" cy="548640"/>
+          </a:xfrm>
+          <a:prstGeom prst="ellipse">
+            <a:avLst/>
+          </a:prstGeom>
+          <a:solidFill>
+            <a:srgbClr val="F96167"/>
+          </a:solidFill>
+          <a:ln/>
+        </p:spPr>
+      </p:sp>
+      <p:pic>
+        <p:nvPicPr>
+          <p:cNvPr id="18" name="Image 2" descr="preencoded.png">    </p:cNvPr>
+          <p:cNvPicPr>
+            <a:picLocks noChangeAspect="1"/>
+          </p:cNvPicPr>
+          <p:nvPr/>
+        </p:nvPicPr>
+        <p:blipFill>
+          <a:blip r:embed="rId3"/>
+          <a:stretch>
+            <a:fillRect/>
+          </a:stretch>
+        </p:blipFill>
+        <p:spPr>
+          <a:xfrm>
+            <a:off x="6369710" y="1751990"/>
+            <a:ext cx="427939" cy="427939"/>
+          </a:xfrm>
+          <a:prstGeom prst="rect">
+            <a:avLst/>
+          </a:prstGeom>
+        </p:spPr>
+      </p:pic>
+      <p:sp>
+        <p:nvSpPr>
+          <p:cNvPr id="19" name="Text 14"/>
+          <p:cNvSpPr/>
+          <p:nvPr/>
+        </p:nvSpPr>
+        <p:spPr>
+          <a:xfrm>
+            <a:off x="7040880" y="1691640"/>
+            <a:ext cx="1554480" cy="548640"/>
+          </a:xfrm>
+          <a:prstGeom prst="rect">
+            <a:avLst/>
+          </a:prstGeom>
+          <a:noFill/>
+          <a:ln/>
+        </p:spPr>
+        <p:txBody>
+          <a:bodyPr wrap="square" lIns="0" tIns="0" rIns="0" bIns="0" rtlCol="0" anchor="ctr"/>
+          <a:lstStyle/>
+          <a:p>
+            <a:pPr indent="0" marL="0">
+              <a:buNone/>
+            </a:pPr>
+            <a:r>
+              <a:rPr lang="en-US" sz="1500" b="1" dirty="0">
+                <a:solidFill>
+                  <a:srgbClr val="2F3C7E"/>
+                </a:solidFill>
+                <a:latin typeface="Georgia" pitchFamily="34" charset="0"/>
+                <a:ea typeface="Georgia" pitchFamily="34" charset="-122"/>
+                <a:cs typeface="Georgia" pitchFamily="34" charset="-120"/>
+              </a:rPr>
+              <a:t>Same levers, same bill</a:t>
+            </a:r>
+            <a:endParaRPr lang="en-US" sz="1500" dirty="0"/>
+          </a:p>
+        </p:txBody>
+      </p:sp>
+      <p:sp>
+        <p:nvSpPr>
+          <p:cNvPr id="20" name="Text 15"/>
+          <p:cNvSpPr/>
+          <p:nvPr/>
+        </p:nvSpPr>
+        <p:spPr>
+          <a:xfrm>
+            <a:off x="6309360" y="2423160"/>
+            <a:ext cx="2240280" cy="1463040"/>
+          </a:xfrm>
+          <a:prstGeom prst="rect">
+            <a:avLst/>
+          </a:prstGeom>
+          <a:noFill/>
+          <a:ln/>
+        </p:spPr>
+        <p:txBody>
+          <a:bodyPr wrap="square" lIns="0" tIns="0" rIns="0" bIns="0" rtlCol="0" anchor="ctr"/>
+          <a:lstStyle/>
+          <a:p>
+            <a:pPr indent="0" marL="0">
+              <a:buNone/>
+            </a:pPr>
+            <a:r>
+              <a:rPr lang="en-US" sz="1250" dirty="0">
+                <a:solidFill>
+                  <a:srgbClr val="4A4038"/>
+                </a:solidFill>
+                <a:latin typeface="Calibri" pitchFamily="34" charset="0"/>
+                <a:ea typeface="Calibri" pitchFamily="34" charset="-122"/>
+                <a:cs typeface="Calibri" pitchFamily="34" charset="-120"/>
+              </a:rPr>
+              <a:t>Model tier + context size (Day 2-4 habits) are exactly what drives the usage-based portion of the bill.</a:t>
+            </a:r>
+            <a:endParaRPr lang="en-US" sz="1250" dirty="0"/>
+          </a:p>
+        </p:txBody>
+      </p:sp>
+      <p:sp>
+        <p:nvSpPr>
+          <p:cNvPr id="21" name="Text 16"/>
+          <p:cNvSpPr/>
+          <p:nvPr/>
+        </p:nvSpPr>
+        <p:spPr>
+          <a:xfrm>
+            <a:off x="548640" y="4709160"/>
+            <a:ext cx="8046720" cy="274320"/>
+          </a:xfrm>
+          <a:prstGeom prst="rect">
+            <a:avLst/>
+          </a:prstGeom>
+          <a:noFill/>
+          <a:ln/>
+        </p:spPr>
+        <p:txBody>
+          <a:bodyPr wrap="square" lIns="0" tIns="0" rIns="0" bIns="0" rtlCol="0" anchor="ctr"/>
+          <a:lstStyle/>
+          <a:p>
+            <a:pPr algn="l" indent="0" marL="0">
+              <a:buNone/>
+            </a:pPr>
+            <a:r>
+              <a:rPr lang="en-US" sz="1000" dirty="0">
+                <a:solidFill>
+                  <a:srgbClr val="B5A78F"/>
+                </a:solidFill>
+                <a:latin typeface="Calibri" pitchFamily="34" charset="0"/>
+                <a:ea typeface="Calibri" pitchFamily="34" charset="-122"/>
+                <a:cs typeface="Calibri" pitchFamily="34" charset="-120"/>
+              </a:rPr>
+              <a:t>copilot-cli-lab · concept</a:t>
+            </a:r>
+            <a:endParaRPr lang="en-US" sz="1000" dirty="0"/>
+          </a:p>
+        </p:txBody>
+      </p:sp>
+    </p:spTree>
+  </p:cSld>
+  <p:clrMapOvr>
+    <a:masterClrMapping/>
+  </p:clrMapOvr>
+</p:sld>
+</file>
+
+<file path=ppt/slides/slide15.xml><?xml version="1.0" encoding="utf-8"?>
+<p:sld xmlns:a="http://schemas.openxmlformats.org/drawingml/2006/main" xmlns:r="http://schemas.openxmlformats.org/officeDocument/2006/relationships" xmlns:p="http://schemas.openxmlformats.org/presentationml/2006/main">
+  <p:cSld name="Slide 15">
+    <p:bg>
+      <p:bgPr>
+        <a:solidFill>
+          <a:srgbClr val="2F3C7E"/>
+        </a:solidFill>
+      </p:bgPr>
+    </p:bg>
+    <p:spTree>
+      <p:nvGrpSpPr>
+        <p:cNvPr id="1" name=""/>
+        <p:cNvGrpSpPr/>
+        <p:nvPr/>
+      </p:nvGrpSpPr>
+      <p:grpSpPr>
+        <a:xfrm>
+          <a:off x="0" y="0"/>
+          <a:ext cx="0" cy="0"/>
+          <a:chOff x="0" y="0"/>
+          <a:chExt cx="0" cy="0"/>
+        </a:xfrm>
+      </p:grpSpPr>
+      <p:sp>
+        <p:nvSpPr>
+          <p:cNvPr id="2" name="Shape 0"/>
+          <p:cNvSpPr/>
+          <p:nvPr/>
+        </p:nvSpPr>
+        <p:spPr>
+          <a:xfrm>
             <a:off x="-1737360" y="-1737360"/>
             <a:ext cx="3291840" cy="3291840"/>
           </a:xfrm>
@@ -4251,7 +6664,7 @@
     <p:bg>
       <p:bgPr>
         <a:solidFill>
-          <a:srgbClr val="2F3C7E"/>
+          <a:srgbClr val="FFF9F0"/>
         </a:solidFill>
       </p:bgPr>
     </p:bg>
@@ -4277,43 +6690,21 @@
         </p:nvSpPr>
         <p:spPr>
           <a:xfrm>
-            <a:off x="7863840" y="3931920"/>
-            <a:ext cx="2377440" cy="2377440"/>
+            <a:off x="457200" y="457200"/>
+            <a:ext cx="731520" cy="731520"/>
           </a:xfrm>
           <a:prstGeom prst="ellipse">
             <a:avLst/>
           </a:prstGeom>
           <a:solidFill>
-            <a:srgbClr val="F96167">
-              <a:alpha val="16000"/>
-            </a:srgbClr>
-          </a:solidFill>
-          <a:ln/>
-        </p:spPr>
-      </p:sp>
-      <p:sp>
-        <p:nvSpPr>
-          <p:cNvPr id="3" name="Shape 1"/>
-          <p:cNvSpPr/>
-          <p:nvPr/>
-        </p:nvSpPr>
-        <p:spPr>
-          <a:xfrm>
-            <a:off x="548640" y="502920"/>
-            <a:ext cx="868680" cy="868680"/>
-          </a:xfrm>
-          <a:prstGeom prst="ellipse">
-            <a:avLst/>
-          </a:prstGeom>
-          <a:solidFill>
-            <a:srgbClr val="F96167"/>
+            <a:srgbClr val="2F3C7E"/>
           </a:solidFill>
           <a:ln/>
         </p:spPr>
       </p:sp>
       <p:pic>
         <p:nvPicPr>
-          <p:cNvPr id="4" name="Image 0" descr="preencoded.png">    </p:cNvPr>
+          <p:cNvPr id="3" name="Image 0" descr="preencoded.png">    </p:cNvPr>
           <p:cNvPicPr>
             <a:picLocks noChangeAspect="1"/>
           </p:cNvPicPr>
@@ -4327,8 +6718,8 @@
         </p:blipFill>
         <p:spPr>
           <a:xfrm>
-            <a:off x="644195" y="598475"/>
-            <a:ext cx="677570" cy="677570"/>
+            <a:off x="537667" y="537667"/>
+            <a:ext cx="570586" cy="570586"/>
           </a:xfrm>
           <a:prstGeom prst="rect">
             <a:avLst/>
@@ -4337,14 +6728,53 @@
       </p:pic>
       <p:sp>
         <p:nvSpPr>
+          <p:cNvPr id="4" name="Text 1"/>
+          <p:cNvSpPr/>
+          <p:nvPr/>
+        </p:nvSpPr>
+        <p:spPr>
+          <a:xfrm>
+            <a:off x="1371600" y="457200"/>
+            <a:ext cx="7315200" cy="640080"/>
+          </a:xfrm>
+          <a:prstGeom prst="rect">
+            <a:avLst/>
+          </a:prstGeom>
+          <a:noFill/>
+          <a:ln/>
+        </p:spPr>
+        <p:txBody>
+          <a:bodyPr wrap="square" lIns="0" tIns="0" rIns="0" bIns="0" rtlCol="0" anchor="ctr"/>
+          <a:lstStyle/>
+          <a:p>
+            <a:pPr indent="0" marL="0">
+              <a:buNone/>
+            </a:pPr>
+            <a:r>
+              <a:rPr lang="en-US" sz="2600" b="1" dirty="0">
+                <a:solidFill>
+                  <a:srgbClr val="2B2118"/>
+                </a:solidFill>
+                <a:latin typeface="Georgia" pitchFamily="34" charset="0"/>
+                <a:ea typeface="Georgia" pitchFamily="34" charset="-122"/>
+                <a:cs typeface="Georgia" pitchFamily="34" charset="-120"/>
+              </a:rPr>
+              <a:t>Context Window &amp; Tokens</a:t>
+            </a:r>
+            <a:endParaRPr lang="en-US" sz="2600" dirty="0"/>
+          </a:p>
+        </p:txBody>
+      </p:sp>
+      <p:sp>
+        <p:nvSpPr>
           <p:cNvPr id="5" name="Text 2"/>
           <p:cNvSpPr/>
           <p:nvPr/>
         </p:nvSpPr>
         <p:spPr>
           <a:xfrm>
-            <a:off x="1600200" y="566928"/>
-            <a:ext cx="3657600" cy="365760"/>
+            <a:off x="457200" y="1188720"/>
+            <a:ext cx="8229600" cy="365760"/>
           </a:xfrm>
           <a:prstGeom prst="rect">
             <a:avLst/>
@@ -4360,56 +6790,56 @@
               <a:buNone/>
             </a:pPr>
             <a:r>
-              <a:rPr lang="en-US" sz="1300" b="1" spc="200" kern="0" dirty="0">
-                <a:solidFill>
-                  <a:srgbClr val="F9E795"/>
+              <a:rPr lang="en-US" sz="1400" i="1" dirty="0">
+                <a:solidFill>
+                  <a:srgbClr val="6B6055"/>
+                </a:solidFill>
+                <a:latin typeface="Calibri" pitchFamily="34" charset="0"/>
+                <a:ea typeface="Calibri" pitchFamily="34" charset="-122"/>
+                <a:cs typeface="Calibri" pitchFamily="34" charset="-120"/>
+              </a:rPr>
+              <a:t>Why the 2nd turn is often cheaper than the 1st</a:t>
+            </a:r>
+            <a:endParaRPr lang="en-US" sz="1400" dirty="0"/>
+          </a:p>
+        </p:txBody>
+      </p:sp>
+      <p:sp>
+        <p:nvSpPr>
+          <p:cNvPr id="6" name="Text 3"/>
+          <p:cNvSpPr/>
+          <p:nvPr/>
+        </p:nvSpPr>
+        <p:spPr>
+          <a:xfrm>
+            <a:off x="457200" y="1783080"/>
+            <a:ext cx="1280160" cy="457200"/>
+          </a:xfrm>
+          <a:prstGeom prst="rect">
+            <a:avLst/>
+          </a:prstGeom>
+          <a:noFill/>
+          <a:ln/>
+        </p:spPr>
+        <p:txBody>
+          <a:bodyPr wrap="square" lIns="0" tIns="0" rIns="0" bIns="0" rtlCol="0" anchor="ctr"/>
+          <a:lstStyle/>
+          <a:p>
+            <a:pPr indent="0" marL="0">
+              <a:buNone/>
+            </a:pPr>
+            <a:r>
+              <a:rPr lang="en-US" sz="1200" b="1" dirty="0">
+                <a:solidFill>
+                  <a:srgbClr val="2F3C7E"/>
                 </a:solidFill>
                 <a:latin typeface="Consolas" pitchFamily="34" charset="0"/>
                 <a:ea typeface="Consolas" pitchFamily="34" charset="-122"/>
                 <a:cs typeface="Consolas" pitchFamily="34" charset="-120"/>
               </a:rPr>
-              <a:t>DAY 3 · LOCAL</a:t>
-            </a:r>
-            <a:endParaRPr lang="en-US" sz="1300" dirty="0"/>
-          </a:p>
-        </p:txBody>
-      </p:sp>
-      <p:sp>
-        <p:nvSpPr>
-          <p:cNvPr id="6" name="Text 3"/>
-          <p:cNvSpPr/>
-          <p:nvPr/>
-        </p:nvSpPr>
-        <p:spPr>
-          <a:xfrm>
-            <a:off x="548640" y="1234440"/>
-            <a:ext cx="8046720" cy="822960"/>
-          </a:xfrm>
-          <a:prstGeom prst="rect">
-            <a:avLst/>
-          </a:prstGeom>
-          <a:noFill/>
-          <a:ln/>
-        </p:spPr>
-        <p:txBody>
-          <a:bodyPr wrap="square" lIns="0" tIns="0" rIns="0" bIns="0" rtlCol="0" anchor="ctr"/>
-          <a:lstStyle/>
-          <a:p>
-            <a:pPr indent="0" marL="0">
-              <a:buNone/>
-            </a:pPr>
-            <a:r>
-              <a:rPr lang="en-US" sz="2600" b="1" dirty="0">
-                <a:solidFill>
-                  <a:srgbClr val="FFFFFF"/>
-                </a:solidFill>
-                <a:latin typeface="Georgia" pitchFamily="34" charset="0"/>
-                <a:ea typeface="Georgia" pitchFamily="34" charset="-122"/>
-                <a:cs typeface="Georgia" pitchFamily="34" charset="-120"/>
-              </a:rPr>
-              <a:t>Project-Local Skills</a:t>
-            </a:r>
-            <a:endParaRPr lang="en-US" sz="2600" dirty="0"/>
+              <a:t>1ST LOOP</a:t>
+            </a:r>
+            <a:endParaRPr lang="en-US" sz="1200" dirty="0"/>
           </a:p>
         </p:txBody>
       </p:sp>
@@ -4421,18 +6851,23 @@
         </p:nvSpPr>
         <p:spPr>
           <a:xfrm>
-            <a:off x="548640" y="2148840"/>
-            <a:ext cx="8046720" cy="1051560"/>
+            <a:off x="1828800" y="1783080"/>
+            <a:ext cx="1371600" cy="502920"/>
           </a:xfrm>
           <a:prstGeom prst="rect">
             <a:avLst/>
           </a:prstGeom>
           <a:solidFill>
-            <a:srgbClr val="FFFFFF">
-              <a:alpha val="8000"/>
+            <a:srgbClr val="F96167">
+              <a:alpha val="90000"/>
             </a:srgbClr>
           </a:solidFill>
-          <a:ln/>
+          <a:ln w="12700">
+            <a:solidFill>
+              <a:srgbClr val="FFFFFF"/>
+            </a:solidFill>
+            <a:prstDash val="solid"/>
+          </a:ln>
         </p:spPr>
       </p:sp>
       <p:sp>
@@ -4443,77 +6878,156 @@
         </p:nvSpPr>
         <p:spPr>
           <a:xfrm>
-            <a:off x="822960" y="2240280"/>
-            <a:ext cx="7498080" cy="868680"/>
-          </a:xfrm>
-          <a:prstGeom prst="rect">
-            <a:avLst/>
-          </a:prstGeom>
-          <a:noFill/>
-          <a:ln/>
-        </p:spPr>
-        <p:txBody>
-          <a:bodyPr wrap="square" lIns="0" tIns="0" rIns="0" bIns="0" rtlCol="0" anchor="ctr"/>
-          <a:lstStyle/>
-          <a:p>
-            <a:pPr indent="0" marL="0">
-              <a:buNone/>
-            </a:pPr>
-            <a:r>
-              <a:rPr lang="en-US" sz="1500" i="1" dirty="0">
-                <a:solidFill>
-                  <a:srgbClr val="FFF9F0"/>
+            <a:off x="1828800" y="1783080"/>
+            <a:ext cx="1371600" cy="502920"/>
+          </a:xfrm>
+          <a:prstGeom prst="rect">
+            <a:avLst/>
+          </a:prstGeom>
+          <a:noFill/>
+          <a:ln/>
+        </p:spPr>
+        <p:txBody>
+          <a:bodyPr wrap="square" lIns="0" tIns="0" rIns="0" bIns="0" rtlCol="0" anchor="ctr"/>
+          <a:lstStyle/>
+          <a:p>
+            <a:pPr algn="ctr" indent="0" marL="0">
+              <a:buNone/>
+            </a:pPr>
+            <a:r>
+              <a:rPr lang="en-US" sz="900" dirty="0">
+                <a:solidFill>
+                  <a:srgbClr val="FFFFFF"/>
                 </a:solidFill>
                 <a:latin typeface="Calibri" pitchFamily="34" charset="0"/>
                 <a:ea typeface="Calibri" pitchFamily="34" charset="-122"/>
                 <a:cs typeface="Calibri" pitchFamily="34" charset="-120"/>
               </a:rPr>
-              <a:t>This codebase has its own quirks global rules don't cover - and real local skills are already set up. Day 3 is about exploring them.</a:t>
-            </a:r>
-            <a:endParaRPr lang="en-US" sz="1500" dirty="0"/>
-          </a:p>
-        </p:txBody>
-      </p:sp>
-      <p:sp>
-        <p:nvSpPr>
-          <p:cNvPr id="9" name="Text 6"/>
-          <p:cNvSpPr/>
-          <p:nvPr/>
-        </p:nvSpPr>
-        <p:spPr>
-          <a:xfrm>
-            <a:off x="548640" y="3429000"/>
-            <a:ext cx="8046720" cy="914400"/>
-          </a:xfrm>
-          <a:prstGeom prst="rect">
-            <a:avLst/>
-          </a:prstGeom>
-          <a:noFill/>
-          <a:ln/>
-        </p:spPr>
-        <p:txBody>
-          <a:bodyPr wrap="square" lIns="0" tIns="0" rIns="0" bIns="0" rtlCol="0" anchor="ctr"/>
-          <a:lstStyle/>
-          <a:p>
-            <a:pPr indent="0" marL="0">
-              <a:buNone/>
-            </a:pPr>
-            <a:r>
-              <a:rPr lang="en-US" sz="1400" b="1" dirty="0">
-                <a:solidFill>
-                  <a:srgbClr val="F9E795"/>
+              <a:t>system prompt &amp; tools</a:t>
+            </a:r>
+            <a:endParaRPr lang="en-US" sz="900" dirty="0"/>
+          </a:p>
+        </p:txBody>
+      </p:sp>
+      <p:sp>
+        <p:nvSpPr>
+          <p:cNvPr id="9" name="Shape 6"/>
+          <p:cNvSpPr/>
+          <p:nvPr/>
+        </p:nvSpPr>
+        <p:spPr>
+          <a:xfrm>
+            <a:off x="3273552" y="1783080"/>
+            <a:ext cx="1371600" cy="502920"/>
+          </a:xfrm>
+          <a:prstGeom prst="rect">
+            <a:avLst/>
+          </a:prstGeom>
+          <a:solidFill>
+            <a:srgbClr val="2F3C7E">
+              <a:alpha val="90000"/>
+            </a:srgbClr>
+          </a:solidFill>
+          <a:ln w="12700">
+            <a:solidFill>
+              <a:srgbClr val="FFFFFF"/>
+            </a:solidFill>
+            <a:prstDash val="solid"/>
+          </a:ln>
+        </p:spPr>
+      </p:sp>
+      <p:sp>
+        <p:nvSpPr>
+          <p:cNvPr id="10" name="Text 7"/>
+          <p:cNvSpPr/>
+          <p:nvPr/>
+        </p:nvSpPr>
+        <p:spPr>
+          <a:xfrm>
+            <a:off x="3273552" y="1783080"/>
+            <a:ext cx="1371600" cy="502920"/>
+          </a:xfrm>
+          <a:prstGeom prst="rect">
+            <a:avLst/>
+          </a:prstGeom>
+          <a:noFill/>
+          <a:ln/>
+        </p:spPr>
+        <p:txBody>
+          <a:bodyPr wrap="square" lIns="0" tIns="0" rIns="0" bIns="0" rtlCol="0" anchor="ctr"/>
+          <a:lstStyle/>
+          <a:p>
+            <a:pPr algn="ctr" indent="0" marL="0">
+              <a:buNone/>
+            </a:pPr>
+            <a:r>
+              <a:rPr lang="en-US" sz="900" dirty="0">
+                <a:solidFill>
+                  <a:srgbClr val="FFFFFF"/>
                 </a:solidFill>
                 <a:latin typeface="Calibri" pitchFamily="34" charset="0"/>
                 <a:ea typeface="Calibri" pitchFamily="34" charset="-122"/>
                 <a:cs typeface="Calibri" pitchFamily="34" charset="-120"/>
               </a:rPr>
-              <a:t>Try it: </a:t>
-            </a:r>
-            <a:pPr indent="0" marL="0">
-              <a:buNone/>
-            </a:pPr>
-            <a:r>
-              <a:rPr lang="en-US" sz="1400" dirty="0">
+              <a:t>prompt</a:t>
+            </a:r>
+            <a:endParaRPr lang="en-US" sz="900" dirty="0"/>
+          </a:p>
+        </p:txBody>
+      </p:sp>
+      <p:sp>
+        <p:nvSpPr>
+          <p:cNvPr id="11" name="Shape 8"/>
+          <p:cNvSpPr/>
+          <p:nvPr/>
+        </p:nvSpPr>
+        <p:spPr>
+          <a:xfrm>
+            <a:off x="4718304" y="1783080"/>
+            <a:ext cx="1371600" cy="502920"/>
+          </a:xfrm>
+          <a:prstGeom prst="rect">
+            <a:avLst/>
+          </a:prstGeom>
+          <a:solidFill>
+            <a:srgbClr val="F96167">
+              <a:alpha val="90000"/>
+            </a:srgbClr>
+          </a:solidFill>
+          <a:ln w="12700">
+            <a:solidFill>
+              <a:srgbClr val="FFFFFF"/>
+            </a:solidFill>
+            <a:prstDash val="solid"/>
+          </a:ln>
+        </p:spPr>
+      </p:sp>
+      <p:sp>
+        <p:nvSpPr>
+          <p:cNvPr id="12" name="Text 9"/>
+          <p:cNvSpPr/>
+          <p:nvPr/>
+        </p:nvSpPr>
+        <p:spPr>
+          <a:xfrm>
+            <a:off x="4718304" y="1783080"/>
+            <a:ext cx="1371600" cy="502920"/>
+          </a:xfrm>
+          <a:prstGeom prst="rect">
+            <a:avLst/>
+          </a:prstGeom>
+          <a:noFill/>
+          <a:ln/>
+        </p:spPr>
+        <p:txBody>
+          <a:bodyPr wrap="square" lIns="0" tIns="0" rIns="0" bIns="0" rtlCol="0" anchor="ctr"/>
+          <a:lstStyle/>
+          <a:p>
+            <a:pPr algn="ctr" indent="0" marL="0">
+              <a:buNone/>
+            </a:pPr>
+            <a:r>
+              <a:rPr lang="en-US" sz="900" dirty="0">
                 <a:solidFill>
                   <a:srgbClr val="FFFFFF"/>
                 </a:solidFill>
@@ -4521,46 +7035,532 @@
                 <a:ea typeface="Calibri" pitchFamily="34" charset="-122"/>
                 <a:cs typeface="Calibri" pitchFamily="34" charset="-120"/>
               </a:rPr>
-              <a:t>Ask Copilot to review the code and watch the pre-built duplicate-task-checker skill kick in.</a:t>
-            </a:r>
-            <a:endParaRPr lang="en-US" sz="1400" dirty="0"/>
-          </a:p>
-        </p:txBody>
-      </p:sp>
-      <p:sp>
-        <p:nvSpPr>
-          <p:cNvPr id="10" name="Text 7"/>
-          <p:cNvSpPr/>
-          <p:nvPr/>
-        </p:nvSpPr>
-        <p:spPr>
-          <a:xfrm>
-            <a:off x="548640" y="4709160"/>
-            <a:ext cx="8046720" cy="274320"/>
-          </a:xfrm>
-          <a:prstGeom prst="rect">
-            <a:avLst/>
-          </a:prstGeom>
-          <a:noFill/>
-          <a:ln/>
-        </p:spPr>
-        <p:txBody>
-          <a:bodyPr wrap="square" lIns="0" tIns="0" rIns="0" bIns="0" rtlCol="0" anchor="ctr"/>
-          <a:lstStyle/>
-          <a:p>
-            <a:pPr algn="l" indent="0" marL="0">
-              <a:buNone/>
-            </a:pPr>
-            <a:r>
-              <a:rPr lang="en-US" sz="1000" dirty="0">
-                <a:solidFill>
-                  <a:srgbClr val="9BA6D6"/>
+              <a:t>file</a:t>
+            </a:r>
+            <a:endParaRPr lang="en-US" sz="900" dirty="0"/>
+          </a:p>
+        </p:txBody>
+      </p:sp>
+      <p:sp>
+        <p:nvSpPr>
+          <p:cNvPr id="13" name="Shape 10"/>
+          <p:cNvSpPr/>
+          <p:nvPr/>
+        </p:nvSpPr>
+        <p:spPr>
+          <a:xfrm>
+            <a:off x="6163056" y="1783080"/>
+            <a:ext cx="1371600" cy="502920"/>
+          </a:xfrm>
+          <a:prstGeom prst="rect">
+            <a:avLst/>
+          </a:prstGeom>
+          <a:solidFill>
+            <a:srgbClr val="2F3C7E">
+              <a:alpha val="90000"/>
+            </a:srgbClr>
+          </a:solidFill>
+          <a:ln w="12700">
+            <a:solidFill>
+              <a:srgbClr val="FFFFFF"/>
+            </a:solidFill>
+            <a:prstDash val="solid"/>
+          </a:ln>
+        </p:spPr>
+      </p:sp>
+      <p:sp>
+        <p:nvSpPr>
+          <p:cNvPr id="14" name="Text 11"/>
+          <p:cNvSpPr/>
+          <p:nvPr/>
+        </p:nvSpPr>
+        <p:spPr>
+          <a:xfrm>
+            <a:off x="6163056" y="1783080"/>
+            <a:ext cx="1371600" cy="502920"/>
+          </a:xfrm>
+          <a:prstGeom prst="rect">
+            <a:avLst/>
+          </a:prstGeom>
+          <a:noFill/>
+          <a:ln/>
+        </p:spPr>
+        <p:txBody>
+          <a:bodyPr wrap="square" lIns="0" tIns="0" rIns="0" bIns="0" rtlCol="0" anchor="ctr"/>
+          <a:lstStyle/>
+          <a:p>
+            <a:pPr algn="ctr" indent="0" marL="0">
+              <a:buNone/>
+            </a:pPr>
+            <a:r>
+              <a:rPr lang="en-US" sz="900" dirty="0">
+                <a:solidFill>
+                  <a:srgbClr val="FFFFFF"/>
                 </a:solidFill>
                 <a:latin typeface="Calibri" pitchFamily="34" charset="0"/>
                 <a:ea typeface="Calibri" pitchFamily="34" charset="-122"/>
                 <a:cs typeface="Calibri" pitchFamily="34" charset="-120"/>
               </a:rPr>
-              <a:t>copilot-cli-lab · day 3 · local</a:t>
+              <a:t>response</a:t>
+            </a:r>
+            <a:endParaRPr lang="en-US" sz="900" dirty="0"/>
+          </a:p>
+        </p:txBody>
+      </p:sp>
+      <p:sp>
+        <p:nvSpPr>
+          <p:cNvPr id="15" name="Text 12"/>
+          <p:cNvSpPr/>
+          <p:nvPr/>
+        </p:nvSpPr>
+        <p:spPr>
+          <a:xfrm>
+            <a:off x="457200" y="2350008"/>
+            <a:ext cx="8046720" cy="320040"/>
+          </a:xfrm>
+          <a:prstGeom prst="rect">
+            <a:avLst/>
+          </a:prstGeom>
+          <a:noFill/>
+          <a:ln/>
+        </p:spPr>
+        <p:txBody>
+          <a:bodyPr wrap="square" lIns="0" tIns="0" rIns="0" bIns="0" rtlCol="0" anchor="ctr"/>
+          <a:lstStyle/>
+          <a:p>
+            <a:pPr indent="0" marL="0">
+              <a:buNone/>
+            </a:pPr>
+            <a:r>
+              <a:rPr lang="en-US" sz="1100" i="1" dirty="0">
+                <a:solidFill>
+                  <a:srgbClr val="6B6055"/>
+                </a:solidFill>
+                <a:latin typeface="Calibri" pitchFamily="34" charset="0"/>
+                <a:ea typeface="Calibri" pitchFamily="34" charset="-122"/>
+                <a:cs typeface="Calibri" pitchFamily="34" charset="-120"/>
+              </a:rPr>
+              <a:t>all billed as input/output tokens</a:t>
+            </a:r>
+            <a:endParaRPr lang="en-US" sz="1100" dirty="0"/>
+          </a:p>
+        </p:txBody>
+      </p:sp>
+      <p:sp>
+        <p:nvSpPr>
+          <p:cNvPr id="16" name="Text 13"/>
+          <p:cNvSpPr/>
+          <p:nvPr/>
+        </p:nvSpPr>
+        <p:spPr>
+          <a:xfrm>
+            <a:off x="457200" y="2880360"/>
+            <a:ext cx="1280160" cy="457200"/>
+          </a:xfrm>
+          <a:prstGeom prst="rect">
+            <a:avLst/>
+          </a:prstGeom>
+          <a:noFill/>
+          <a:ln/>
+        </p:spPr>
+        <p:txBody>
+          <a:bodyPr wrap="square" lIns="0" tIns="0" rIns="0" bIns="0" rtlCol="0" anchor="ctr"/>
+          <a:lstStyle/>
+          <a:p>
+            <a:pPr indent="0" marL="0">
+              <a:buNone/>
+            </a:pPr>
+            <a:r>
+              <a:rPr lang="en-US" sz="1200" b="1" dirty="0">
+                <a:solidFill>
+                  <a:srgbClr val="2F3C7E"/>
+                </a:solidFill>
+                <a:latin typeface="Consolas" pitchFamily="34" charset="0"/>
+                <a:ea typeface="Consolas" pitchFamily="34" charset="-122"/>
+                <a:cs typeface="Consolas" pitchFamily="34" charset="-120"/>
+              </a:rPr>
+              <a:t>2ND LOOP</a:t>
+            </a:r>
+            <a:endParaRPr lang="en-US" sz="1200" dirty="0"/>
+          </a:p>
+        </p:txBody>
+      </p:sp>
+      <p:sp>
+        <p:nvSpPr>
+          <p:cNvPr id="17" name="Shape 14"/>
+          <p:cNvSpPr/>
+          <p:nvPr/>
+        </p:nvSpPr>
+        <p:spPr>
+          <a:xfrm>
+            <a:off x="1828800" y="2880360"/>
+            <a:ext cx="2377440" cy="502920"/>
+          </a:xfrm>
+          <a:prstGeom prst="rect">
+            <a:avLst/>
+          </a:prstGeom>
+          <a:solidFill>
+            <a:srgbClr val="F9E795">
+              <a:alpha val="90000"/>
+            </a:srgbClr>
+          </a:solidFill>
+          <a:ln w="12700">
+            <a:solidFill>
+              <a:srgbClr val="FFFFFF"/>
+            </a:solidFill>
+            <a:prstDash val="solid"/>
+          </a:ln>
+        </p:spPr>
+      </p:sp>
+      <p:sp>
+        <p:nvSpPr>
+          <p:cNvPr id="18" name="Text 15"/>
+          <p:cNvSpPr/>
+          <p:nvPr/>
+        </p:nvSpPr>
+        <p:spPr>
+          <a:xfrm>
+            <a:off x="1828800" y="2880360"/>
+            <a:ext cx="2377440" cy="502920"/>
+          </a:xfrm>
+          <a:prstGeom prst="rect">
+            <a:avLst/>
+          </a:prstGeom>
+          <a:noFill/>
+          <a:ln/>
+        </p:spPr>
+        <p:txBody>
+          <a:bodyPr wrap="square" lIns="0" tIns="0" rIns="0" bIns="0" rtlCol="0" anchor="ctr"/>
+          <a:lstStyle/>
+          <a:p>
+            <a:pPr algn="ctr" indent="0" marL="0">
+              <a:buNone/>
+            </a:pPr>
+            <a:r>
+              <a:rPr lang="en-US" sz="900" dirty="0">
+                <a:solidFill>
+                  <a:srgbClr val="2B2118"/>
+                </a:solidFill>
+                <a:latin typeface="Calibri" pitchFamily="34" charset="0"/>
+                <a:ea typeface="Calibri" pitchFamily="34" charset="-122"/>
+                <a:cs typeface="Calibri" pitchFamily="34" charset="-120"/>
+              </a:rPr>
+              <a:t>cached: system prompt, prompt, file, response</a:t>
+            </a:r>
+            <a:endParaRPr lang="en-US" sz="900" dirty="0"/>
+          </a:p>
+        </p:txBody>
+      </p:sp>
+      <p:sp>
+        <p:nvSpPr>
+          <p:cNvPr id="19" name="Shape 16"/>
+          <p:cNvSpPr/>
+          <p:nvPr/>
+        </p:nvSpPr>
+        <p:spPr>
+          <a:xfrm>
+            <a:off x="4279392" y="2880360"/>
+            <a:ext cx="1371600" cy="502920"/>
+          </a:xfrm>
+          <a:prstGeom prst="rect">
+            <a:avLst/>
+          </a:prstGeom>
+          <a:solidFill>
+            <a:srgbClr val="2F3C7E">
+              <a:alpha val="90000"/>
+            </a:srgbClr>
+          </a:solidFill>
+          <a:ln w="12700">
+            <a:solidFill>
+              <a:srgbClr val="FFFFFF"/>
+            </a:solidFill>
+            <a:prstDash val="solid"/>
+          </a:ln>
+        </p:spPr>
+      </p:sp>
+      <p:sp>
+        <p:nvSpPr>
+          <p:cNvPr id="20" name="Text 17"/>
+          <p:cNvSpPr/>
+          <p:nvPr/>
+        </p:nvSpPr>
+        <p:spPr>
+          <a:xfrm>
+            <a:off x="4279392" y="2880360"/>
+            <a:ext cx="1371600" cy="502920"/>
+          </a:xfrm>
+          <a:prstGeom prst="rect">
+            <a:avLst/>
+          </a:prstGeom>
+          <a:noFill/>
+          <a:ln/>
+        </p:spPr>
+        <p:txBody>
+          <a:bodyPr wrap="square" lIns="0" tIns="0" rIns="0" bIns="0" rtlCol="0" anchor="ctr"/>
+          <a:lstStyle/>
+          <a:p>
+            <a:pPr algn="ctr" indent="0" marL="0">
+              <a:buNone/>
+            </a:pPr>
+            <a:r>
+              <a:rPr lang="en-US" sz="900" dirty="0">
+                <a:solidFill>
+                  <a:srgbClr val="FFFFFF"/>
+                </a:solidFill>
+                <a:latin typeface="Calibri" pitchFamily="34" charset="0"/>
+                <a:ea typeface="Calibri" pitchFamily="34" charset="-122"/>
+                <a:cs typeface="Calibri" pitchFamily="34" charset="-120"/>
+              </a:rPr>
+              <a:t>new prompt</a:t>
+            </a:r>
+            <a:endParaRPr lang="en-US" sz="900" dirty="0"/>
+          </a:p>
+        </p:txBody>
+      </p:sp>
+      <p:sp>
+        <p:nvSpPr>
+          <p:cNvPr id="21" name="Shape 18"/>
+          <p:cNvSpPr/>
+          <p:nvPr/>
+        </p:nvSpPr>
+        <p:spPr>
+          <a:xfrm>
+            <a:off x="5724144" y="2880360"/>
+            <a:ext cx="1371600" cy="502920"/>
+          </a:xfrm>
+          <a:prstGeom prst="rect">
+            <a:avLst/>
+          </a:prstGeom>
+          <a:solidFill>
+            <a:srgbClr val="F96167">
+              <a:alpha val="90000"/>
+            </a:srgbClr>
+          </a:solidFill>
+          <a:ln w="12700">
+            <a:solidFill>
+              <a:srgbClr val="FFFFFF"/>
+            </a:solidFill>
+            <a:prstDash val="solid"/>
+          </a:ln>
+        </p:spPr>
+      </p:sp>
+      <p:sp>
+        <p:nvSpPr>
+          <p:cNvPr id="22" name="Text 19"/>
+          <p:cNvSpPr/>
+          <p:nvPr/>
+        </p:nvSpPr>
+        <p:spPr>
+          <a:xfrm>
+            <a:off x="5724144" y="2880360"/>
+            <a:ext cx="1371600" cy="502920"/>
+          </a:xfrm>
+          <a:prstGeom prst="rect">
+            <a:avLst/>
+          </a:prstGeom>
+          <a:noFill/>
+          <a:ln/>
+        </p:spPr>
+        <p:txBody>
+          <a:bodyPr wrap="square" lIns="0" tIns="0" rIns="0" bIns="0" rtlCol="0" anchor="ctr"/>
+          <a:lstStyle/>
+          <a:p>
+            <a:pPr algn="ctr" indent="0" marL="0">
+              <a:buNone/>
+            </a:pPr>
+            <a:r>
+              <a:rPr lang="en-US" sz="900" dirty="0">
+                <a:solidFill>
+                  <a:srgbClr val="FFFFFF"/>
+                </a:solidFill>
+                <a:latin typeface="Calibri" pitchFamily="34" charset="0"/>
+                <a:ea typeface="Calibri" pitchFamily="34" charset="-122"/>
+                <a:cs typeface="Calibri" pitchFamily="34" charset="-120"/>
+              </a:rPr>
+              <a:t>new file</a:t>
+            </a:r>
+            <a:endParaRPr lang="en-US" sz="900" dirty="0"/>
+          </a:p>
+        </p:txBody>
+      </p:sp>
+      <p:sp>
+        <p:nvSpPr>
+          <p:cNvPr id="23" name="Shape 20"/>
+          <p:cNvSpPr/>
+          <p:nvPr/>
+        </p:nvSpPr>
+        <p:spPr>
+          <a:xfrm>
+            <a:off x="7168896" y="2880360"/>
+            <a:ext cx="1371600" cy="502920"/>
+          </a:xfrm>
+          <a:prstGeom prst="rect">
+            <a:avLst/>
+          </a:prstGeom>
+          <a:solidFill>
+            <a:srgbClr val="2F3C7E">
+              <a:alpha val="90000"/>
+            </a:srgbClr>
+          </a:solidFill>
+          <a:ln w="12700">
+            <a:solidFill>
+              <a:srgbClr val="FFFFFF"/>
+            </a:solidFill>
+            <a:prstDash val="solid"/>
+          </a:ln>
+        </p:spPr>
+      </p:sp>
+      <p:sp>
+        <p:nvSpPr>
+          <p:cNvPr id="24" name="Text 21"/>
+          <p:cNvSpPr/>
+          <p:nvPr/>
+        </p:nvSpPr>
+        <p:spPr>
+          <a:xfrm>
+            <a:off x="7168896" y="2880360"/>
+            <a:ext cx="1371600" cy="502920"/>
+          </a:xfrm>
+          <a:prstGeom prst="rect">
+            <a:avLst/>
+          </a:prstGeom>
+          <a:noFill/>
+          <a:ln/>
+        </p:spPr>
+        <p:txBody>
+          <a:bodyPr wrap="square" lIns="0" tIns="0" rIns="0" bIns="0" rtlCol="0" anchor="ctr"/>
+          <a:lstStyle/>
+          <a:p>
+            <a:pPr algn="ctr" indent="0" marL="0">
+              <a:buNone/>
+            </a:pPr>
+            <a:r>
+              <a:rPr lang="en-US" sz="900" dirty="0">
+                <a:solidFill>
+                  <a:srgbClr val="FFFFFF"/>
+                </a:solidFill>
+                <a:latin typeface="Calibri" pitchFamily="34" charset="0"/>
+                <a:ea typeface="Calibri" pitchFamily="34" charset="-122"/>
+                <a:cs typeface="Calibri" pitchFamily="34" charset="-120"/>
+              </a:rPr>
+              <a:t>response</a:t>
+            </a:r>
+            <a:endParaRPr lang="en-US" sz="900" dirty="0"/>
+          </a:p>
+        </p:txBody>
+      </p:sp>
+      <p:sp>
+        <p:nvSpPr>
+          <p:cNvPr id="25" name="Text 22"/>
+          <p:cNvSpPr/>
+          <p:nvPr/>
+        </p:nvSpPr>
+        <p:spPr>
+          <a:xfrm>
+            <a:off x="457200" y="3447288"/>
+            <a:ext cx="8046720" cy="320040"/>
+          </a:xfrm>
+          <a:prstGeom prst="rect">
+            <a:avLst/>
+          </a:prstGeom>
+          <a:noFill/>
+          <a:ln/>
+        </p:spPr>
+        <p:txBody>
+          <a:bodyPr wrap="square" lIns="0" tIns="0" rIns="0" bIns="0" rtlCol="0" anchor="ctr"/>
+          <a:lstStyle/>
+          <a:p>
+            <a:pPr indent="0" marL="0">
+              <a:buNone/>
+            </a:pPr>
+            <a:r>
+              <a:rPr lang="en-US" sz="1100" i="1" dirty="0">
+                <a:solidFill>
+                  <a:srgbClr val="6B6055"/>
+                </a:solidFill>
+                <a:latin typeface="Calibri" pitchFamily="34" charset="0"/>
+                <a:ea typeface="Calibri" pitchFamily="34" charset="-122"/>
+                <a:cs typeface="Calibri" pitchFamily="34" charset="-120"/>
+              </a:rPr>
+              <a:t>cache input tokens - not guaranteed, usually cheaper</a:t>
+            </a:r>
+            <a:endParaRPr lang="en-US" sz="1100" dirty="0"/>
+          </a:p>
+        </p:txBody>
+      </p:sp>
+      <p:sp>
+        <p:nvSpPr>
+          <p:cNvPr id="26" name="Text 23"/>
+          <p:cNvSpPr/>
+          <p:nvPr/>
+        </p:nvSpPr>
+        <p:spPr>
+          <a:xfrm>
+            <a:off x="457200" y="4160520"/>
+            <a:ext cx="8229600" cy="548640"/>
+          </a:xfrm>
+          <a:prstGeom prst="rect">
+            <a:avLst/>
+          </a:prstGeom>
+          <a:noFill/>
+          <a:ln/>
+        </p:spPr>
+        <p:txBody>
+          <a:bodyPr wrap="square" lIns="0" tIns="0" rIns="0" bIns="0" rtlCol="0" anchor="ctr"/>
+          <a:lstStyle/>
+          <a:p>
+            <a:pPr indent="0" marL="0">
+              <a:buNone/>
+            </a:pPr>
+            <a:r>
+              <a:rPr lang="en-US" sz="1300" dirty="0">
+                <a:solidFill>
+                  <a:srgbClr val="2F3C7E"/>
+                </a:solidFill>
+                <a:latin typeface="Calibri" pitchFamily="34" charset="0"/>
+                <a:ea typeface="Calibri" pitchFamily="34" charset="-122"/>
+                <a:cs typeface="Calibri" pitchFamily="34" charset="-120"/>
+              </a:rPr>
+              <a:t>Small, stable global instructions &amp; local skills (Day 2/3) are prime candidates for caching - they rarely change between turns.</a:t>
+            </a:r>
+            <a:endParaRPr lang="en-US" sz="1300" dirty="0"/>
+          </a:p>
+        </p:txBody>
+      </p:sp>
+      <p:sp>
+        <p:nvSpPr>
+          <p:cNvPr id="27" name="Text 24"/>
+          <p:cNvSpPr/>
+          <p:nvPr/>
+        </p:nvSpPr>
+        <p:spPr>
+          <a:xfrm>
+            <a:off x="548640" y="4709160"/>
+            <a:ext cx="8046720" cy="274320"/>
+          </a:xfrm>
+          <a:prstGeom prst="rect">
+            <a:avLst/>
+          </a:prstGeom>
+          <a:noFill/>
+          <a:ln/>
+        </p:spPr>
+        <p:txBody>
+          <a:bodyPr wrap="square" lIns="0" tIns="0" rIns="0" bIns="0" rtlCol="0" anchor="ctr"/>
+          <a:lstStyle/>
+          <a:p>
+            <a:pPr algn="l" indent="0" marL="0">
+              <a:buNone/>
+            </a:pPr>
+            <a:r>
+              <a:rPr lang="en-US" sz="1000" dirty="0">
+                <a:solidFill>
+                  <a:srgbClr val="B5A78F"/>
+                </a:solidFill>
+                <a:latin typeface="Calibri" pitchFamily="34" charset="0"/>
+                <a:ea typeface="Calibri" pitchFamily="34" charset="-122"/>
+                <a:cs typeface="Calibri" pitchFamily="34" charset="-120"/>
+              </a:rPr>
+              <a:t>copilot-cli-lab · concept</a:t>
             </a:r>
             <a:endParaRPr lang="en-US" sz="1000" dirty="0"/>
           </a:p>
@@ -4580,7 +7580,7 @@
     <p:bg>
       <p:bgPr>
         <a:solidFill>
-          <a:srgbClr val="2F3C7E"/>
+          <a:srgbClr val="FFF9F0"/>
         </a:solidFill>
       </p:bgPr>
     </p:bg>
@@ -4600,38 +7600,126 @@
       </p:grpSpPr>
       <p:sp>
         <p:nvSpPr>
-          <p:cNvPr id="2" name="Shape 0"/>
-          <p:cNvSpPr/>
-          <p:nvPr/>
-        </p:nvSpPr>
-        <p:spPr>
-          <a:xfrm>
-            <a:off x="7863840" y="3931920"/>
-            <a:ext cx="2377440" cy="2377440"/>
-          </a:xfrm>
-          <a:prstGeom prst="ellipse">
+          <p:cNvPr id="2" name="Text 0"/>
+          <p:cNvSpPr/>
+          <p:nvPr/>
+        </p:nvSpPr>
+        <p:spPr>
+          <a:xfrm>
+            <a:off x="457200" y="411480"/>
+            <a:ext cx="8229600" cy="548640"/>
+          </a:xfrm>
+          <a:prstGeom prst="rect">
+            <a:avLst/>
+          </a:prstGeom>
+          <a:noFill/>
+          <a:ln/>
+        </p:spPr>
+        <p:txBody>
+          <a:bodyPr wrap="square" lIns="0" tIns="0" rIns="0" bIns="0" rtlCol="0" anchor="ctr"/>
+          <a:lstStyle/>
+          <a:p>
+            <a:pPr indent="0" marL="0">
+              <a:buNone/>
+            </a:pPr>
+            <a:r>
+              <a:rPr lang="en-US" sz="2800" b="1" dirty="0">
+                <a:solidFill>
+                  <a:srgbClr val="2B2118"/>
+                </a:solidFill>
+                <a:latin typeface="Georgia" pitchFamily="34" charset="0"/>
+                <a:ea typeface="Georgia" pitchFamily="34" charset="-122"/>
+                <a:cs typeface="Georgia" pitchFamily="34" charset="-120"/>
+              </a:rPr>
+              <a:t>The Two Biggest Levers</a:t>
+            </a:r>
+            <a:endParaRPr lang="en-US" sz="2800" dirty="0"/>
+          </a:p>
+        </p:txBody>
+      </p:sp>
+      <p:sp>
+        <p:nvSpPr>
+          <p:cNvPr id="3" name="Text 1"/>
+          <p:cNvSpPr/>
+          <p:nvPr/>
+        </p:nvSpPr>
+        <p:spPr>
+          <a:xfrm>
+            <a:off x="457200" y="960120"/>
+            <a:ext cx="8229600" cy="365760"/>
+          </a:xfrm>
+          <a:prstGeom prst="rect">
+            <a:avLst/>
+          </a:prstGeom>
+          <a:noFill/>
+          <a:ln/>
+        </p:spPr>
+        <p:txBody>
+          <a:bodyPr wrap="square" lIns="0" tIns="0" rIns="0" bIns="0" rtlCol="0" anchor="ctr"/>
+          <a:lstStyle/>
+          <a:p>
+            <a:pPr indent="0" marL="0">
+              <a:buNone/>
+            </a:pPr>
+            <a:r>
+              <a:rPr lang="en-US" sz="1400" i="1" dirty="0">
+                <a:solidFill>
+                  <a:srgbClr val="6B6055"/>
+                </a:solidFill>
+                <a:latin typeface="Calibri" pitchFamily="34" charset="0"/>
+                <a:ea typeface="Calibri" pitchFamily="34" charset="-122"/>
+                <a:cs typeface="Calibri" pitchFamily="34" charset="-120"/>
+              </a:rPr>
+              <a:t>for optimizing quality &amp; tokens</a:t>
+            </a:r>
+            <a:endParaRPr lang="en-US" sz="1400" dirty="0"/>
+          </a:p>
+        </p:txBody>
+      </p:sp>
+      <p:sp>
+        <p:nvSpPr>
+          <p:cNvPr id="4" name="Shape 2"/>
+          <p:cNvSpPr/>
+          <p:nvPr/>
+        </p:nvSpPr>
+        <p:spPr>
+          <a:xfrm>
+            <a:off x="457200" y="1508760"/>
+            <a:ext cx="3931920" cy="3246120"/>
+          </a:xfrm>
+          <a:prstGeom prst="rect">
             <a:avLst/>
           </a:prstGeom>
           <a:solidFill>
-            <a:srgbClr val="F96167">
-              <a:alpha val="16000"/>
-            </a:srgbClr>
+            <a:srgbClr val="FFFFFF"/>
           </a:solidFill>
-          <a:ln/>
-        </p:spPr>
-      </p:sp>
-      <p:sp>
-        <p:nvSpPr>
-          <p:cNvPr id="3" name="Shape 1"/>
-          <p:cNvSpPr/>
-          <p:nvPr/>
-        </p:nvSpPr>
-        <p:spPr>
-          <a:xfrm>
-            <a:off x="548640" y="502920"/>
-            <a:ext cx="868680" cy="868680"/>
-          </a:xfrm>
-          <a:prstGeom prst="ellipse">
+          <a:ln w="12700">
+            <a:solidFill>
+              <a:srgbClr val="EFE3D3"/>
+            </a:solidFill>
+            <a:prstDash val="solid"/>
+          </a:ln>
+          <a:effectLst>
+            <a:outerShdw sx="100000" sy="100000" kx="0" ky="0" algn="bl" rotWithShape="0" blurRad="76200" dist="25400" dir="8100000">
+              <a:srgbClr val="000000">
+                <a:alpha val="10000"/>
+              </a:srgbClr>
+            </a:outerShdw>
+          </a:effectLst>
+        </p:spPr>
+      </p:sp>
+      <p:sp>
+        <p:nvSpPr>
+          <p:cNvPr id="5" name="Shape 3"/>
+          <p:cNvSpPr/>
+          <p:nvPr/>
+        </p:nvSpPr>
+        <p:spPr>
+          <a:xfrm>
+            <a:off x="457200" y="1508760"/>
+            <a:ext cx="3931920" cy="109728"/>
+          </a:xfrm>
+          <a:prstGeom prst="rect">
             <a:avLst/>
           </a:prstGeom>
           <a:solidFill>
@@ -4640,9 +7728,29 @@
           <a:ln/>
         </p:spPr>
       </p:sp>
+      <p:sp>
+        <p:nvSpPr>
+          <p:cNvPr id="6" name="Shape 4"/>
+          <p:cNvSpPr/>
+          <p:nvPr/>
+        </p:nvSpPr>
+        <p:spPr>
+          <a:xfrm>
+            <a:off x="685800" y="1783080"/>
+            <a:ext cx="548640" cy="548640"/>
+          </a:xfrm>
+          <a:prstGeom prst="ellipse">
+            <a:avLst/>
+          </a:prstGeom>
+          <a:solidFill>
+            <a:srgbClr val="2F3C7E"/>
+          </a:solidFill>
+          <a:ln/>
+        </p:spPr>
+      </p:sp>
       <p:pic>
         <p:nvPicPr>
-          <p:cNvPr id="4" name="Image 0" descr="preencoded.png">    </p:cNvPr>
+          <p:cNvPr id="7" name="Image 0" descr="preencoded.png">    </p:cNvPr>
           <p:cNvPicPr>
             <a:picLocks noChangeAspect="1"/>
           </p:cNvPicPr>
@@ -4656,8 +7764,8 @@
         </p:blipFill>
         <p:spPr>
           <a:xfrm>
-            <a:off x="644195" y="598475"/>
-            <a:ext cx="677570" cy="677570"/>
+            <a:off x="746150" y="1843430"/>
+            <a:ext cx="427939" cy="427939"/>
           </a:xfrm>
           <a:prstGeom prst="rect">
             <a:avLst/>
@@ -4666,14 +7774,14 @@
       </p:pic>
       <p:sp>
         <p:nvSpPr>
-          <p:cNvPr id="5" name="Text 2"/>
-          <p:cNvSpPr/>
-          <p:nvPr/>
-        </p:nvSpPr>
-        <p:spPr>
-          <a:xfrm>
-            <a:off x="1600200" y="566928"/>
-            <a:ext cx="3657600" cy="365760"/>
+          <p:cNvPr id="8" name="Text 5"/>
+          <p:cNvSpPr/>
+          <p:nvPr/>
+        </p:nvSpPr>
+        <p:spPr>
+          <a:xfrm>
+            <a:off x="1417320" y="1783080"/>
+            <a:ext cx="2834640" cy="548640"/>
           </a:xfrm>
           <a:prstGeom prst="rect">
             <a:avLst/>
@@ -4689,207 +7797,395 @@
               <a:buNone/>
             </a:pPr>
             <a:r>
-              <a:rPr lang="en-US" sz="1300" b="1" spc="200" kern="0" dirty="0">
-                <a:solidFill>
-                  <a:srgbClr val="F9E795"/>
-                </a:solidFill>
-                <a:latin typeface="Consolas" pitchFamily="34" charset="0"/>
-                <a:ea typeface="Consolas" pitchFamily="34" charset="-122"/>
-                <a:cs typeface="Consolas" pitchFamily="34" charset="-120"/>
-              </a:rPr>
-              <a:t>DAY 4 · COST-SAVING</a:t>
-            </a:r>
-            <a:endParaRPr lang="en-US" sz="1300" dirty="0"/>
-          </a:p>
-        </p:txBody>
-      </p:sp>
-      <p:sp>
-        <p:nvSpPr>
-          <p:cNvPr id="6" name="Text 3"/>
-          <p:cNvSpPr/>
-          <p:nvPr/>
-        </p:nvSpPr>
-        <p:spPr>
-          <a:xfrm>
-            <a:off x="548640" y="1234440"/>
-            <a:ext cx="8046720" cy="822960"/>
-          </a:xfrm>
-          <a:prstGeom prst="rect">
-            <a:avLst/>
-          </a:prstGeom>
-          <a:noFill/>
-          <a:ln/>
-        </p:spPr>
-        <p:txBody>
-          <a:bodyPr wrap="square" lIns="0" tIns="0" rIns="0" bIns="0" rtlCol="0" anchor="ctr"/>
-          <a:lstStyle/>
-          <a:p>
-            <a:pPr indent="0" marL="0">
-              <a:buNone/>
-            </a:pPr>
-            <a:r>
-              <a:rPr lang="en-US" sz="2600" b="1" dirty="0">
-                <a:solidFill>
-                  <a:srgbClr val="FFFFFF"/>
+              <a:rPr lang="en-US" sz="1500" b="1" dirty="0">
+                <a:solidFill>
+                  <a:srgbClr val="2F3C7E"/>
                 </a:solidFill>
                 <a:latin typeface="Georgia" pitchFamily="34" charset="0"/>
                 <a:ea typeface="Georgia" pitchFamily="34" charset="-122"/>
                 <a:cs typeface="Georgia" pitchFamily="34" charset="-120"/>
               </a:rPr>
-              <a:t>Working Smart, Not Expensive</a:t>
-            </a:r>
-            <a:endParaRPr lang="en-US" sz="2600" dirty="0"/>
-          </a:p>
-        </p:txBody>
-      </p:sp>
-      <p:sp>
-        <p:nvSpPr>
-          <p:cNvPr id="7" name="Shape 4"/>
-          <p:cNvSpPr/>
-          <p:nvPr/>
-        </p:nvSpPr>
-        <p:spPr>
-          <a:xfrm>
-            <a:off x="548640" y="2148840"/>
-            <a:ext cx="8046720" cy="1051560"/>
-          </a:xfrm>
-          <a:prstGeom prst="rect">
-            <a:avLst/>
-          </a:prstGeom>
-          <a:solidFill>
-            <a:srgbClr val="FFFFFF">
-              <a:alpha val="8000"/>
-            </a:srgbClr>
-          </a:solidFill>
-          <a:ln/>
-        </p:spPr>
-      </p:sp>
-      <p:sp>
-        <p:nvSpPr>
-          <p:cNvPr id="8" name="Text 5"/>
-          <p:cNvSpPr/>
-          <p:nvPr/>
-        </p:nvSpPr>
-        <p:spPr>
-          <a:xfrm>
-            <a:off x="822960" y="2240280"/>
-            <a:ext cx="7498080" cy="868680"/>
-          </a:xfrm>
-          <a:prstGeom prst="rect">
-            <a:avLst/>
-          </a:prstGeom>
-          <a:noFill/>
-          <a:ln/>
-        </p:spPr>
-        <p:txBody>
-          <a:bodyPr wrap="square" lIns="0" tIns="0" rIns="0" bIns="0" rtlCol="0" anchor="ctr"/>
-          <a:lstStyle/>
-          <a:p>
-            <a:pPr indent="0" marL="0">
-              <a:buNone/>
-            </a:pPr>
-            <a:r>
-              <a:rPr lang="en-US" sz="1500" i="1" dirty="0">
-                <a:solidFill>
-                  <a:srgbClr val="FFF9F0"/>
+              <a:t>Model choice &amp; auto mode</a:t>
+            </a:r>
+            <a:endParaRPr lang="en-US" sz="1500" dirty="0"/>
+          </a:p>
+        </p:txBody>
+      </p:sp>
+      <p:sp>
+        <p:nvSpPr>
+          <p:cNvPr id="9" name="Text 6"/>
+          <p:cNvSpPr/>
+          <p:nvPr/>
+        </p:nvSpPr>
+        <p:spPr>
+          <a:xfrm>
+            <a:off x="685800" y="2423160"/>
+            <a:ext cx="3520440" cy="2194560"/>
+          </a:xfrm>
+          <a:prstGeom prst="rect">
+            <a:avLst/>
+          </a:prstGeom>
+          <a:noFill/>
+          <a:ln/>
+        </p:spPr>
+        <p:txBody>
+          <a:bodyPr wrap="square" rtlCol="0" anchor="ctr"/>
+          <a:lstStyle/>
+          <a:p>
+            <a:pPr marL="342900" indent="-342900">
+              <a:spcAft>
+                <a:spcPts val="800"/>
+              </a:spcAft>
+              <a:buSzPct val="100000"/>
+              <a:buChar char="•"/>
+            </a:pPr>
+            <a:r>
+              <a:rPr lang="en-US" sz="1250" dirty="0">
+                <a:solidFill>
+                  <a:srgbClr val="4A4038"/>
                 </a:solidFill>
                 <a:latin typeface="Calibri" pitchFamily="34" charset="0"/>
                 <a:ea typeface="Calibri" pitchFamily="34" charset="-122"/>
                 <a:cs typeface="Calibri" pitchFamily="34" charset="-120"/>
               </a:rPr>
-              <a:t>A visible new feature, one lingering bug, six cost-saving habits, plus three tool-choice habits: grep/glob over bash, file refs not pastes, subagents for exploration.</a:t>
-            </a:r>
-            <a:endParaRPr lang="en-US" sz="1500" dirty="0"/>
-          </a:p>
-        </p:txBody>
-      </p:sp>
-      <p:sp>
-        <p:nvSpPr>
-          <p:cNvPr id="9" name="Text 6"/>
-          <p:cNvSpPr/>
-          <p:nvPr/>
-        </p:nvSpPr>
-        <p:spPr>
-          <a:xfrm>
-            <a:off x="548640" y="3429000"/>
-            <a:ext cx="8046720" cy="914400"/>
-          </a:xfrm>
-          <a:prstGeom prst="rect">
-            <a:avLst/>
-          </a:prstGeom>
-          <a:noFill/>
-          <a:ln/>
-        </p:spPr>
-        <p:txBody>
-          <a:bodyPr wrap="square" lIns="0" tIns="0" rIns="0" bIns="0" rtlCol="0" anchor="ctr"/>
-          <a:lstStyle/>
-          <a:p>
-            <a:pPr indent="0" marL="0">
-              <a:buNone/>
-            </a:pPr>
-            <a:r>
-              <a:rPr lang="en-US" sz="1400" b="1" dirty="0">
-                <a:solidFill>
-                  <a:srgbClr val="F9E795"/>
+              <a:t>Reasoning models (Opus, GPT-5.5) - sync tasks: planning, debugging</a:t>
+            </a:r>
+            <a:endParaRPr lang="en-US" sz="1250" dirty="0"/>
+          </a:p>
+          <a:p>
+            <a:pPr marL="342900" indent="-342900">
+              <a:spcAft>
+                <a:spcPts val="800"/>
+              </a:spcAft>
+              <a:buSzPct val="100000"/>
+              <a:buChar char="•"/>
+            </a:pPr>
+            <a:r>
+              <a:rPr lang="en-US" sz="1250" dirty="0">
+                <a:solidFill>
+                  <a:srgbClr val="4A4038"/>
                 </a:solidFill>
                 <a:latin typeface="Calibri" pitchFamily="34" charset="0"/>
                 <a:ea typeface="Calibri" pitchFamily="34" charset="-122"/>
                 <a:cs typeface="Calibri" pitchFamily="34" charset="-120"/>
               </a:rPr>
-              <a:t>Try it: </a:t>
-            </a:r>
-            <a:pPr indent="0" marL="0">
-              <a:buNone/>
-            </a:pPr>
-            <a:r>
-              <a:rPr lang="en-US" sz="1400" dirty="0">
-                <a:solidFill>
-                  <a:srgbClr val="FFFFFF"/>
+              <a:t>Mid-tier (Sonnet, GPT-5.4) - everyday async implementation</a:t>
+            </a:r>
+            <a:endParaRPr lang="en-US" sz="1250" dirty="0"/>
+          </a:p>
+          <a:p>
+            <a:pPr marL="342900" indent="-342900">
+              <a:spcAft>
+                <a:spcPts val="800"/>
+              </a:spcAft>
+              <a:buSzPct val="100000"/>
+              <a:buChar char="•"/>
+            </a:pPr>
+            <a:r>
+              <a:rPr lang="en-US" sz="1250" dirty="0">
+                <a:solidFill>
+                  <a:srgbClr val="4A4038"/>
                 </a:solidFill>
                 <a:latin typeface="Calibri" pitchFamily="34" charset="0"/>
                 <a:ea typeface="Calibri" pitchFamily="34" charset="-122"/>
                 <a:cs typeface="Calibri" pitchFamily="34" charset="-120"/>
               </a:rPr>
-              <a:t>Ship color-coded priority badges, fix the duplicate task-id bug, then watch /context and /usage prove the savings.</a:t>
-            </a:r>
-            <a:endParaRPr lang="en-US" sz="1400" dirty="0"/>
-          </a:p>
-        </p:txBody>
-      </p:sp>
-      <p:sp>
-        <p:nvSpPr>
-          <p:cNvPr id="10" name="Text 7"/>
-          <p:cNvSpPr/>
-          <p:nvPr/>
-        </p:nvSpPr>
-        <p:spPr>
-          <a:xfrm>
-            <a:off x="548640" y="4709160"/>
-            <a:ext cx="8046720" cy="274320"/>
-          </a:xfrm>
-          <a:prstGeom prst="rect">
-            <a:avLst/>
-          </a:prstGeom>
-          <a:noFill/>
-          <a:ln/>
-        </p:spPr>
-        <p:txBody>
-          <a:bodyPr wrap="square" lIns="0" tIns="0" rIns="0" bIns="0" rtlCol="0" anchor="ctr"/>
-          <a:lstStyle/>
-          <a:p>
-            <a:pPr algn="l" indent="0" marL="0">
-              <a:buNone/>
-            </a:pPr>
-            <a:r>
-              <a:rPr lang="en-US" sz="1000" dirty="0">
-                <a:solidFill>
-                  <a:srgbClr val="9BA6D6"/>
+              <a:t>Light-tier (Haiku, GPT-mini) - small, repetitive refactors</a:t>
+            </a:r>
+            <a:endParaRPr lang="en-US" sz="1250" dirty="0"/>
+          </a:p>
+          <a:p>
+            <a:pPr marL="342900" indent="-342900">
+              <a:buSzPct val="100000"/>
+              <a:buChar char="•"/>
+            </a:pPr>
+            <a:r>
+              <a:rPr lang="en-US" sz="1250" dirty="0">
+                <a:solidFill>
+                  <a:srgbClr val="4A4038"/>
                 </a:solidFill>
                 <a:latin typeface="Calibri" pitchFamily="34" charset="0"/>
                 <a:ea typeface="Calibri" pitchFamily="34" charset="-122"/>
                 <a:cs typeface="Calibri" pitchFamily="34" charset="-120"/>
               </a:rPr>
-              <a:t>copilot-cli-lab · day 4 · cost-saving</a:t>
+              <a:t>Auto Mode - a fine, lazy default when unsure</a:t>
+            </a:r>
+            <a:endParaRPr lang="en-US" sz="1250" dirty="0"/>
+          </a:p>
+        </p:txBody>
+      </p:sp>
+      <p:sp>
+        <p:nvSpPr>
+          <p:cNvPr id="10" name="Shape 7"/>
+          <p:cNvSpPr/>
+          <p:nvPr/>
+        </p:nvSpPr>
+        <p:spPr>
+          <a:xfrm>
+            <a:off x="4709160" y="1508760"/>
+            <a:ext cx="3977640" cy="3246120"/>
+          </a:xfrm>
+          <a:prstGeom prst="rect">
+            <a:avLst/>
+          </a:prstGeom>
+          <a:solidFill>
+            <a:srgbClr val="FFFFFF"/>
+          </a:solidFill>
+          <a:ln w="12700">
+            <a:solidFill>
+              <a:srgbClr val="EFE3D3"/>
+            </a:solidFill>
+            <a:prstDash val="solid"/>
+          </a:ln>
+          <a:effectLst>
+            <a:outerShdw sx="100000" sy="100000" kx="0" ky="0" algn="bl" rotWithShape="0" blurRad="76200" dist="25400" dir="8100000">
+              <a:srgbClr val="000000">
+                <a:alpha val="10000"/>
+              </a:srgbClr>
+            </a:outerShdw>
+          </a:effectLst>
+        </p:spPr>
+      </p:sp>
+      <p:sp>
+        <p:nvSpPr>
+          <p:cNvPr id="11" name="Shape 8"/>
+          <p:cNvSpPr/>
+          <p:nvPr/>
+        </p:nvSpPr>
+        <p:spPr>
+          <a:xfrm>
+            <a:off x="4709160" y="1508760"/>
+            <a:ext cx="3977640" cy="109728"/>
+          </a:xfrm>
+          <a:prstGeom prst="rect">
+            <a:avLst/>
+          </a:prstGeom>
+          <a:solidFill>
+            <a:srgbClr val="F9E795"/>
+          </a:solidFill>
+          <a:ln/>
+        </p:spPr>
+      </p:sp>
+      <p:sp>
+        <p:nvSpPr>
+          <p:cNvPr id="12" name="Shape 9"/>
+          <p:cNvSpPr/>
+          <p:nvPr/>
+        </p:nvSpPr>
+        <p:spPr>
+          <a:xfrm>
+            <a:off x="4937760" y="1783080"/>
+            <a:ext cx="548640" cy="548640"/>
+          </a:xfrm>
+          <a:prstGeom prst="ellipse">
+            <a:avLst/>
+          </a:prstGeom>
+          <a:solidFill>
+            <a:srgbClr val="2F3C7E"/>
+          </a:solidFill>
+          <a:ln/>
+        </p:spPr>
+      </p:sp>
+      <p:pic>
+        <p:nvPicPr>
+          <p:cNvPr id="13" name="Image 1" descr="preencoded.png">    </p:cNvPr>
+          <p:cNvPicPr>
+            <a:picLocks noChangeAspect="1"/>
+          </p:cNvPicPr>
+          <p:nvPr/>
+        </p:nvPicPr>
+        <p:blipFill>
+          <a:blip r:embed="rId2"/>
+          <a:stretch>
+            <a:fillRect/>
+          </a:stretch>
+        </p:blipFill>
+        <p:spPr>
+          <a:xfrm>
+            <a:off x="4998110" y="1843430"/>
+            <a:ext cx="427939" cy="427939"/>
+          </a:xfrm>
+          <a:prstGeom prst="rect">
+            <a:avLst/>
+          </a:prstGeom>
+        </p:spPr>
+      </p:pic>
+      <p:sp>
+        <p:nvSpPr>
+          <p:cNvPr id="14" name="Text 10"/>
+          <p:cNvSpPr/>
+          <p:nvPr/>
+        </p:nvSpPr>
+        <p:spPr>
+          <a:xfrm>
+            <a:off x="5669280" y="1783080"/>
+            <a:ext cx="2880360" cy="548640"/>
+          </a:xfrm>
+          <a:prstGeom prst="rect">
+            <a:avLst/>
+          </a:prstGeom>
+          <a:noFill/>
+          <a:ln/>
+        </p:spPr>
+        <p:txBody>
+          <a:bodyPr wrap="square" lIns="0" tIns="0" rIns="0" bIns="0" rtlCol="0" anchor="ctr"/>
+          <a:lstStyle/>
+          <a:p>
+            <a:pPr indent="0" marL="0">
+              <a:buNone/>
+            </a:pPr>
+            <a:r>
+              <a:rPr lang="en-US" sz="1500" b="1" dirty="0">
+                <a:solidFill>
+                  <a:srgbClr val="2F3C7E"/>
+                </a:solidFill>
+                <a:latin typeface="Georgia" pitchFamily="34" charset="0"/>
+                <a:ea typeface="Georgia" pitchFamily="34" charset="-122"/>
+                <a:cs typeface="Georgia" pitchFamily="34" charset="-120"/>
+              </a:rPr>
+              <a:t>Provide only relevant context</a:t>
+            </a:r>
+            <a:endParaRPr lang="en-US" sz="1500" dirty="0"/>
+          </a:p>
+        </p:txBody>
+      </p:sp>
+      <p:sp>
+        <p:nvSpPr>
+          <p:cNvPr id="15" name="Text 11"/>
+          <p:cNvSpPr/>
+          <p:nvPr/>
+        </p:nvSpPr>
+        <p:spPr>
+          <a:xfrm>
+            <a:off x="4937760" y="2423160"/>
+            <a:ext cx="3566160" cy="2194560"/>
+          </a:xfrm>
+          <a:prstGeom prst="rect">
+            <a:avLst/>
+          </a:prstGeom>
+          <a:noFill/>
+          <a:ln/>
+        </p:spPr>
+        <p:txBody>
+          <a:bodyPr wrap="square" rtlCol="0" anchor="ctr"/>
+          <a:lstStyle/>
+          <a:p>
+            <a:pPr marL="342900" indent="-342900">
+              <a:spcAft>
+                <a:spcPts val="800"/>
+              </a:spcAft>
+              <a:buSzPct val="100000"/>
+              <a:buChar char="•"/>
+            </a:pPr>
+            <a:r>
+              <a:rPr lang="en-US" sz="1250" dirty="0">
+                <a:solidFill>
+                  <a:srgbClr val="4A4038"/>
+                </a:solidFill>
+                <a:latin typeface="Calibri" pitchFamily="34" charset="0"/>
+                <a:ea typeface="Calibri" pitchFamily="34" charset="-122"/>
+                <a:cs typeface="Calibri" pitchFamily="34" charset="-120"/>
+              </a:rPr>
+              <a:t>As much as required, as little as necessary</a:t>
+            </a:r>
+            <a:endParaRPr lang="en-US" sz="1250" dirty="0"/>
+          </a:p>
+          <a:p>
+            <a:pPr marL="342900" indent="-342900">
+              <a:spcAft>
+                <a:spcPts val="800"/>
+              </a:spcAft>
+              <a:buSzPct val="100000"/>
+              <a:buChar char="•"/>
+            </a:pPr>
+            <a:r>
+              <a:rPr lang="en-US" sz="1250" dirty="0">
+                <a:solidFill>
+                  <a:srgbClr val="4A4038"/>
+                </a:solidFill>
+                <a:latin typeface="Calibri" pitchFamily="34" charset="0"/>
+                <a:ea typeface="Calibri" pitchFamily="34" charset="-122"/>
+                <a:cs typeface="Calibri" pitchFamily="34" charset="-120"/>
+              </a:rPr>
+              <a:t>Reference files by path - don't paste 50K-char blobs</a:t>
+            </a:r>
+            <a:endParaRPr lang="en-US" sz="1250" dirty="0"/>
+          </a:p>
+          <a:p>
+            <a:pPr marL="342900" indent="-342900">
+              <a:spcAft>
+                <a:spcPts val="800"/>
+              </a:spcAft>
+              <a:buSzPct val="100000"/>
+              <a:buChar char="•"/>
+            </a:pPr>
+            <a:r>
+              <a:rPr lang="en-US" sz="1250" dirty="0">
+                <a:solidFill>
+                  <a:srgbClr val="4A4038"/>
+                </a:solidFill>
+                <a:latin typeface="Calibri" pitchFamily="34" charset="0"/>
+                <a:ea typeface="Calibri" pitchFamily="34" charset="-122"/>
+                <a:cs typeface="Calibri" pitchFamily="34" charset="-120"/>
+              </a:rPr>
+              <a:t>/clear or start a new session often</a:t>
+            </a:r>
+            <a:endParaRPr lang="en-US" sz="1250" dirty="0"/>
+          </a:p>
+          <a:p>
+            <a:pPr marL="342900" indent="-342900">
+              <a:buSzPct val="100000"/>
+              <a:buChar char="•"/>
+            </a:pPr>
+            <a:r>
+              <a:rPr lang="en-US" sz="1250" dirty="0">
+                <a:solidFill>
+                  <a:srgbClr val="4A4038"/>
+                </a:solidFill>
+                <a:latin typeface="Calibri" pitchFamily="34" charset="0"/>
+                <a:ea typeface="Calibri" pitchFamily="34" charset="-122"/>
+                <a:cs typeface="Calibri" pitchFamily="34" charset="-120"/>
+              </a:rPr>
+              <a:t>Delegate heavy exploration to subagents</a:t>
+            </a:r>
+            <a:endParaRPr lang="en-US" sz="1250" dirty="0"/>
+          </a:p>
+        </p:txBody>
+      </p:sp>
+      <p:sp>
+        <p:nvSpPr>
+          <p:cNvPr id="16" name="Text 12"/>
+          <p:cNvSpPr/>
+          <p:nvPr/>
+        </p:nvSpPr>
+        <p:spPr>
+          <a:xfrm>
+            <a:off x="548640" y="4709160"/>
+            <a:ext cx="8046720" cy="274320"/>
+          </a:xfrm>
+          <a:prstGeom prst="rect">
+            <a:avLst/>
+          </a:prstGeom>
+          <a:noFill/>
+          <a:ln/>
+        </p:spPr>
+        <p:txBody>
+          <a:bodyPr wrap="square" lIns="0" tIns="0" rIns="0" bIns="0" rtlCol="0" anchor="ctr"/>
+          <a:lstStyle/>
+          <a:p>
+            <a:pPr algn="l" indent="0" marL="0">
+              <a:buNone/>
+            </a:pPr>
+            <a:r>
+              <a:rPr lang="en-US" sz="1000" dirty="0">
+                <a:solidFill>
+                  <a:srgbClr val="B5A78F"/>
+                </a:solidFill>
+                <a:latin typeface="Calibri" pitchFamily="34" charset="0"/>
+                <a:ea typeface="Calibri" pitchFamily="34" charset="-122"/>
+                <a:cs typeface="Calibri" pitchFamily="34" charset="-120"/>
+              </a:rPr>
+              <a:t>copilot-cli-lab · concept</a:t>
             </a:r>
             <a:endParaRPr lang="en-US" sz="1000" dirty="0"/>
           </a:p>
@@ -5026,7 +8322,7 @@
                 <a:ea typeface="Consolas" pitchFamily="34" charset="-122"/>
                 <a:cs typeface="Consolas" pitchFamily="34" charset="-120"/>
               </a:rPr>
-              <a:t>DAY 5 · AUTOMATE</a:t>
+              <a:t>DAY 3 · LOCAL</a:t>
             </a:r>
             <a:endParaRPr lang="en-US" sz="1300" dirty="0"/>
           </a:p>
@@ -5065,7 +8361,7 @@
                 <a:ea typeface="Georgia" pitchFamily="34" charset="-122"/>
                 <a:cs typeface="Georgia" pitchFamily="34" charset="-120"/>
               </a:rPr>
-              <a:t>Automating the Busywork</a:t>
+              <a:t>Project-Local Skills</a:t>
             </a:r>
             <a:endParaRPr lang="en-US" sz="2600" dirty="0"/>
           </a:p>
@@ -5126,7 +8422,7 @@
                 <a:ea typeface="Calibri" pitchFamily="34" charset="-122"/>
                 <a:cs typeface="Calibri" pitchFamily="34" charset="-120"/>
               </a:rPr>
-              <a:t>Start dumb-simple: one /every prompt that reports token usage daily. Then level up with a ready-made GitHub Copilot App template.</a:t>
+              <a:t>This codebase has its own quirks global rules don't cover - and real local skills are already set up. Day 3 is about exploring them.</a:t>
             </a:r>
             <a:endParaRPr lang="en-US" sz="1500" dirty="0"/>
           </a:p>
@@ -5179,7 +8475,7 @@
                 <a:ea typeface="Calibri" pitchFamily="34" charset="-122"/>
                 <a:cs typeface="Calibri" pitchFamily="34" charset="-120"/>
               </a:rPr>
-              <a:t>Schedule the one-line token-usage check, then browse the Copilot App's automation templates for the real morning report.</a:t>
+              <a:t>Ask Copilot to review the code and watch the pre-built duplicate-task-checker skill kick in.</a:t>
             </a:r>
             <a:endParaRPr lang="en-US" sz="1400" dirty="0"/>
           </a:p>
@@ -5218,7 +8514,7 @@
                 <a:ea typeface="Calibri" pitchFamily="34" charset="-122"/>
                 <a:cs typeface="Calibri" pitchFamily="34" charset="-120"/>
               </a:rPr>
-              <a:t>copilot-cli-lab · day 5 · automate</a:t>
+              <a:t>copilot-cli-lab · day 3 · local</a:t>
             </a:r>
             <a:endParaRPr lang="en-US" sz="1000" dirty="0"/>
           </a:p>
@@ -5355,7 +8651,7 @@
                 <a:ea typeface="Consolas" pitchFamily="34" charset="-122"/>
                 <a:cs typeface="Consolas" pitchFamily="34" charset="-120"/>
               </a:rPr>
-              <a:t>DAY 6 · SHOW OFF</a:t>
+              <a:t>DAY 4 · COST-SAVING</a:t>
             </a:r>
             <a:endParaRPr lang="en-US" sz="1300" dirty="0"/>
           </a:p>
@@ -5394,7 +8690,7 @@
                 <a:ea typeface="Georgia" pitchFamily="34" charset="-122"/>
                 <a:cs typeface="Georgia" pitchFamily="34" charset="-120"/>
               </a:rPr>
-              <a:t>Build the Deck With /pptx</a:t>
+              <a:t>Working Smart, Not Expensive</a:t>
             </a:r>
             <a:endParaRPr lang="en-US" sz="2600" dirty="0"/>
           </a:p>
@@ -5455,7 +8751,7 @@
                 <a:ea typeface="Calibri" pitchFamily="34" charset="-122"/>
                 <a:cs typeface="Calibri" pitchFamily="34" charset="-120"/>
               </a:rPr>
-              <a:t>The same pptx skill that built this deck can build yours - straight from this repo's READMEs and commit history.</a:t>
+              <a:t>A visible new feature, one lingering bug, six cost-saving habits, plus three tool-choice habits: grep/glob over bash, file refs not pastes, subagents for exploration.</a:t>
             </a:r>
             <a:endParaRPr lang="en-US" sz="1500" dirty="0"/>
           </a:p>
@@ -5508,7 +8804,7 @@
                 <a:ea typeface="Calibri" pitchFamily="34" charset="-122"/>
                 <a:cs typeface="Calibri" pitchFamily="34" charset="-120"/>
               </a:rPr>
-              <a:t>Ask Copilot to build a 6-8 slide demo-day deck from this repo, then present it in under 2 minutes.</a:t>
+              <a:t>Ship color-coded priority badges, fix the duplicate task-id bug, then watch /context and /usage prove the savings.</a:t>
             </a:r>
             <a:endParaRPr lang="en-US" sz="1400" dirty="0"/>
           </a:p>
@@ -5547,7 +8843,7 @@
                 <a:ea typeface="Calibri" pitchFamily="34" charset="-122"/>
                 <a:cs typeface="Calibri" pitchFamily="34" charset="-120"/>
               </a:rPr>
-              <a:t>copilot-cli-lab · day 6 · show off</a:t>
+              <a:t>copilot-cli-lab · day 4 · cost-saving</a:t>
             </a:r>
             <a:endParaRPr lang="en-US" sz="1000" dirty="0"/>
           </a:p>

</xml_diff>